<commit_message>
feat(strategy): update partnership model with 4.2M users, POP, Tours Movilnet, k capital and Waterfall 75/25
</commit_message>
<xml_diff>
--- a/docs/PRESENTACION_EJECUTIVA_MOVILNET_IA.pptx
+++ b/docs/PRESENTACION_EJECUTIVA_MOVILNET_IA.pptx
@@ -3206,14 +3206,14 @@
           <a:lstStyle/>
           <a:p>
             <a:pPr>
-              <a:defRPr sz="1200" b="1">
+              <a:defRPr sz="1150" b="1">
                 <a:solidFill>
                   <a:srgbClr val="E62020"/>
                 </a:solidFill>
               </a:defRPr>
             </a:pPr>
             <a:r>
-              <a:t>DOSSIER EJECUTIVO ESTRATÉGICO &amp; PLAN FINANCIERO</a:t>
+              <a:t>DOSSIER ESTRATÉGICO DE INVERSIÓN &amp; MODELO COMERCIAL</a:t>
             </a:r>
           </a:p>
           <a:p>
@@ -3221,7 +3221,7 @@
               <a:spcBef>
                 <a:spcPts val="800"/>
               </a:spcBef>
-              <a:defRPr sz="3600" b="1">
+              <a:defRPr sz="3400" b="1">
                 <a:solidFill>
                   <a:srgbClr val="FFFFFF"/>
                 </a:solidFill>
@@ -3236,14 +3236,14 @@
               <a:spcBef>
                 <a:spcPts val="800"/>
               </a:spcBef>
-              <a:defRPr sz="1700">
+              <a:defRPr sz="1550">
                 <a:solidFill>
                   <a:srgbClr val="CBD5E1"/>
                 </a:solidFill>
               </a:defRPr>
             </a:pPr>
             <a:r>
-              <a:t>De Centro de Costos Operativos a Canal Dominante de Nuevos Ingresos Recurrentes</a:t>
+              <a:t>Alianza Público-Privada: Aporte en Canales de Movilnet (4.2M Usuarios + Marketing) &amp; Capital Privado Tecnológico</a:t>
             </a:r>
           </a:p>
           <a:p>
@@ -3251,14 +3251,14 @@
               <a:spcBef>
                 <a:spcPts val="1400"/>
               </a:spcBef>
-              <a:defRPr sz="1200">
+              <a:defRPr sz="1150">
                 <a:solidFill>
                   <a:srgbClr val="94A3B8"/>
                 </a:solidFill>
               </a:defRPr>
             </a:pPr>
             <a:r>
-              <a:t>Telecomunicaciones Movilnet C.A.  •  WhatsApp Master + PWA con Cero Consumo de Datos</a:t>
+              <a:t>Telecomunicaciones Movilnet C.A.  •  WhatsApp Master (+58 424 153 3712) + PWA con Cero Consumo de Datos</a:t>
             </a:r>
           </a:p>
         </p:txBody>
@@ -3312,7 +3312,7 @@
               </a:defRPr>
             </a:pPr>
             <a:r>
-              <a:t>PAYBACK INVERSIÓN</a:t>
+              <a:t>BASE CAUTIVA MOVILNET</a:t>
             </a:r>
           </a:p>
           <a:p>
@@ -3320,14 +3320,14 @@
               <a:spcBef>
                 <a:spcPts val="400"/>
               </a:spcBef>
-              <a:defRPr sz="2400" b="1">
-                <a:solidFill>
-                  <a:srgbClr val="10B981"/>
-                </a:solidFill>
-              </a:defRPr>
-            </a:pPr>
-            <a:r>
-              <a:t>7.2 Meses</a:t>
+              <a:defRPr sz="2300" b="1">
+                <a:solidFill>
+                  <a:srgbClr val="0EA5E9"/>
+                </a:solidFill>
+              </a:defRPr>
+            </a:pPr>
+            <a:r>
+              <a:t>4.2M Usuarios</a:t>
             </a:r>
           </a:p>
           <a:p>
@@ -3342,7 +3342,7 @@
               </a:defRPr>
             </a:pPr>
             <a:r>
-              <a:t>Retorno acelerado por ahorro OPEX</a:t>
+              <a:t>Acceso directo inmediato (CAC = $0)</a:t>
             </a:r>
           </a:p>
         </p:txBody>
@@ -3396,7 +3396,7 @@
               </a:defRPr>
             </a:pPr>
             <a:r>
-              <a:t>TIR ANUAL (IRR)</a:t>
+              <a:t>APORTE DE MARKETING</a:t>
             </a:r>
           </a:p>
           <a:p>
@@ -3404,14 +3404,14 @@
               <a:spcBef>
                 <a:spcPts val="400"/>
               </a:spcBef>
-              <a:defRPr sz="2400" b="1">
-                <a:solidFill>
-                  <a:srgbClr val="10B981"/>
-                </a:solidFill>
-              </a:defRPr>
-            </a:pPr>
-            <a:r>
-              <a:t>68.4%</a:t>
+              <a:defRPr sz="2300" b="1">
+                <a:solidFill>
+                  <a:srgbClr val="F59E0B"/>
+                </a:solidFill>
+              </a:defRPr>
+            </a:pPr>
+            <a:r>
+              <a:t>100% Cubierto</a:t>
             </a:r>
           </a:p>
           <a:p>
@@ -3426,7 +3426,7 @@
               </a:defRPr>
             </a:pPr>
             <a:r>
-              <a:t>WACC descontado al 15%</a:t>
+              <a:t>POP, Banderines, Tours y RRSS por Movilnet</a:t>
             </a:r>
           </a:p>
         </p:txBody>
@@ -3480,7 +3480,7 @@
               </a:defRPr>
             </a:pPr>
             <a:r>
-              <a:t>OPEN RATE WHATSAPP</a:t>
+              <a:t>PAYBACK INVERSIÓN</a:t>
             </a:r>
           </a:p>
           <a:p>
@@ -3488,14 +3488,14 @@
               <a:spcBef>
                 <a:spcPts val="400"/>
               </a:spcBef>
-              <a:defRPr sz="2400" b="1">
-                <a:solidFill>
-                  <a:srgbClr val="F59E0B"/>
-                </a:solidFill>
-              </a:defRPr>
-            </a:pPr>
-            <a:r>
-              <a:t>98.2%</a:t>
+              <a:defRPr sz="2300" b="1">
+                <a:solidFill>
+                  <a:srgbClr val="10B981"/>
+                </a:solidFill>
+              </a:defRPr>
+            </a:pPr>
+            <a:r>
+              <a:t>6.2 Meses</a:t>
             </a:r>
           </a:p>
           <a:p>
@@ -3510,7 +3510,7 @@
               </a:defRPr>
             </a:pPr>
             <a:r>
-              <a:t>vs. 12.4% SMS tradicional</a:t>
+              <a:t>Retorno acelerado por Revenue Share 75/25</a:t>
             </a:r>
           </a:p>
         </p:txBody>
@@ -3564,7 +3564,7 @@
               </a:defRPr>
             </a:pPr>
             <a:r>
-              <a:t>COSTO MARGINAL</a:t>
+              <a:t>TIR ANUAL (IRR)</a:t>
             </a:r>
           </a:p>
           <a:p>
@@ -3572,14 +3572,14 @@
               <a:spcBef>
                 <a:spcPts val="400"/>
               </a:spcBef>
-              <a:defRPr sz="2400" b="1">
-                <a:solidFill>
-                  <a:srgbClr val="0EA5E9"/>
-                </a:solidFill>
-              </a:defRPr>
-            </a:pPr>
-            <a:r>
-              <a:t>→ $0.00</a:t>
+              <a:defRPr sz="2300" b="1">
+                <a:solidFill>
+                  <a:srgbClr val="10B981"/>
+                </a:solidFill>
+              </a:defRPr>
+            </a:pPr>
+            <a:r>
+              <a:t>74.6%</a:t>
             </a:r>
           </a:p>
           <a:p>
@@ -3594,7 +3594,7 @@
               </a:defRPr>
             </a:pPr>
             <a:r>
-              <a:t>$0.85 humano vs. $0.0044 IA</a:t>
+              <a:t>Flujo recurrente libre de riesgo de demanda</a:t>
             </a:r>
           </a:p>
         </p:txBody>
@@ -3740,7 +3740,7 @@
               </a:defRPr>
             </a:pPr>
             <a:r>
-              <a:t>Estructura de Capital Solicitado y Próximos Pasos</a:t>
+              <a:t>Estructura de Capital Privado ($450k) y Plan de Retorno</a:t>
             </a:r>
           </a:p>
           <a:p>
@@ -3755,7 +3755,7 @@
               </a:defRPr>
             </a:pPr>
             <a:r>
-              <a:t>Presupuesto de USD $850.000 estructurado en 3 tramos auditables contra entregables.</a:t>
+              <a:t>100% de la inversión asignada a tecnología e IA. Retorno acelerado mediante Revenue Share 75/25.</a:t>
             </a:r>
           </a:p>
         </p:txBody>
@@ -3769,7 +3769,7 @@
         <p:spPr>
           <a:xfrm>
             <a:off x="731520" y="1645920"/>
-            <a:ext cx="3429000" cy="3108960"/>
+            <a:ext cx="3429000" cy="3017520"/>
           </a:xfrm>
           <a:prstGeom prst="roundRect">
             <a:avLst/>
@@ -3804,33 +3804,33 @@
             <a:pPr algn="ctr">
               <a:defRPr sz="1100" b="1">
                 <a:solidFill>
+                  <a:srgbClr val="FFFFFF"/>
+                </a:solidFill>
+              </a:defRPr>
+            </a:pPr>
+            <a:r>
+              <a:t>TRAMO 1: Desembolso Inmediato</a:t>
+            </a:r>
+          </a:p>
+          <a:p>
+            <a:pPr>
+              <a:spcBef>
+                <a:spcPts val="300"/>
+              </a:spcBef>
+              <a:defRPr sz="1700" b="1">
+                <a:solidFill>
                   <a:srgbClr val="E62020"/>
                 </a:solidFill>
               </a:defRPr>
             </a:pPr>
             <a:r>
-              <a:t>TRAMO 1 (Desembolso Inmediato)</a:t>
-            </a:r>
-          </a:p>
-          <a:p>
-            <a:pPr>
-              <a:spcBef>
-                <a:spcPts val="400"/>
-              </a:spcBef>
-              <a:defRPr sz="1700" b="1">
-                <a:solidFill>
-                  <a:srgbClr val="FFFFFF"/>
-                </a:solidFill>
-              </a:defRPr>
-            </a:pPr>
-            <a:r>
-              <a:t>$340.000 USD (40%)</a:t>
-            </a:r>
-          </a:p>
-          <a:p>
-            <a:pPr>
-              <a:spcBef>
-                <a:spcPts val="1000"/>
+              <a:t>$225.000 USD (50%)</a:t>
+            </a:r>
+          </a:p>
+          <a:p>
+            <a:pPr>
+              <a:spcBef>
+                <a:spcPts val="800"/>
               </a:spcBef>
               <a:defRPr sz="950">
                 <a:solidFill>
@@ -3839,11 +3839,11 @@
               </a:defRPr>
             </a:pPr>
             <a:r>
-              <a:t>• Infraestructura elástica y redundancia en Render Cloud.</a:t>
+              <a:t>• Clúster elástico en la nube y edge CDN.</a:t>
             </a:r>
             <a:br/>
             <a:r>
-              <a:t>• Aseguramiento del canal WhatsApp Enterprise.</a:t>
+              <a:t>• Aseguramiento del gateway WhatsApp Enterprise.</a:t>
             </a:r>
             <a:br/>
             <a:r>
@@ -3861,7 +3861,7 @@
         <p:spPr>
           <a:xfrm>
             <a:off x="4343400" y="1645920"/>
-            <a:ext cx="3429000" cy="3108960"/>
+            <a:ext cx="3429000" cy="3017520"/>
           </a:xfrm>
           <a:prstGeom prst="roundRect">
             <a:avLst/>
@@ -3896,33 +3896,33 @@
             <a:pPr algn="ctr">
               <a:defRPr sz="1100" b="1">
                 <a:solidFill>
+                  <a:srgbClr val="FFFFFF"/>
+                </a:solidFill>
+              </a:defRPr>
+            </a:pPr>
+            <a:r>
+              <a:t>TRAMO 2: Mes 2 de Operación</a:t>
+            </a:r>
+          </a:p>
+          <a:p>
+            <a:pPr>
+              <a:spcBef>
+                <a:spcPts val="300"/>
+              </a:spcBef>
+              <a:defRPr sz="1700" b="1">
+                <a:solidFill>
                   <a:srgbClr val="F59E0B"/>
                 </a:solidFill>
               </a:defRPr>
             </a:pPr>
             <a:r>
-              <a:t>TRAMO 2 (Mes 3 de Operación)</a:t>
-            </a:r>
-          </a:p>
-          <a:p>
-            <a:pPr>
-              <a:spcBef>
-                <a:spcPts val="400"/>
-              </a:spcBef>
-              <a:defRPr sz="1700" b="1">
-                <a:solidFill>
-                  <a:srgbClr val="FFFFFF"/>
-                </a:solidFill>
-              </a:defRPr>
-            </a:pPr>
-            <a:r>
-              <a:t>$297.500 USD (35%)</a:t>
-            </a:r>
-          </a:p>
-          <a:p>
-            <a:pPr>
-              <a:spcBef>
-                <a:spcPts val="1000"/>
+              <a:t>$135.000 USD (30%)</a:t>
+            </a:r>
+          </a:p>
+          <a:p>
+            <a:pPr>
+              <a:spcBef>
+                <a:spcPts val="800"/>
               </a:spcBef>
               <a:defRPr sz="950">
                 <a:solidFill>
@@ -3931,15 +3931,15 @@
               </a:defRPr>
             </a:pPr>
             <a:r>
-              <a:t>• Homologación masiva C2P con los 18 bancos nacionales.</a:t>
+              <a:t>• Homologación masiva C2P con 18 bancos.</a:t>
             </a:r>
             <a:br/>
             <a:r>
-              <a:t>• Onboarding de 150 comercios aliados en Cazador.</a:t>
+              <a:t>• Onboarding de 150 comercios en Cazador.</a:t>
             </a:r>
             <a:br/>
             <a:r>
-              <a:t>• Motor OCR avanzado para comprobantes bancarios.</a:t>
+              <a:t>• Motor OCR Gemini Flash para comprobantes.</a:t>
             </a:r>
           </a:p>
         </p:txBody>
@@ -3953,7 +3953,7 @@
         <p:spPr>
           <a:xfrm>
             <a:off x="7955280" y="1645920"/>
-            <a:ext cx="3429000" cy="3108960"/>
+            <a:ext cx="3429000" cy="3017520"/>
           </a:xfrm>
           <a:prstGeom prst="roundRect">
             <a:avLst/>
@@ -3988,33 +3988,33 @@
             <a:pPr algn="ctr">
               <a:defRPr sz="1100" b="1">
                 <a:solidFill>
+                  <a:srgbClr val="FFFFFF"/>
+                </a:solidFill>
+              </a:defRPr>
+            </a:pPr>
+            <a:r>
+              <a:t>TRAMO 3: Mes 4 de Operación</a:t>
+            </a:r>
+          </a:p>
+          <a:p>
+            <a:pPr>
+              <a:spcBef>
+                <a:spcPts val="300"/>
+              </a:spcBef>
+              <a:defRPr sz="1700" b="1">
+                <a:solidFill>
                   <a:srgbClr val="10B981"/>
                 </a:solidFill>
               </a:defRPr>
             </a:pPr>
             <a:r>
-              <a:t>TRAMO 3 (Mes 6 de Operación)</a:t>
-            </a:r>
-          </a:p>
-          <a:p>
-            <a:pPr>
-              <a:spcBef>
-                <a:spcPts val="400"/>
-              </a:spcBef>
-              <a:defRPr sz="1700" b="1">
-                <a:solidFill>
-                  <a:srgbClr val="FFFFFF"/>
-                </a:solidFill>
-              </a:defRPr>
-            </a:pPr>
-            <a:r>
-              <a:t>$212.500 USD (25%)</a:t>
-            </a:r>
-          </a:p>
-          <a:p>
-            <a:pPr>
-              <a:spcBef>
-                <a:spcPts val="1000"/>
+              <a:t>$90.000 USD (20%)</a:t>
+            </a:r>
+          </a:p>
+          <a:p>
+            <a:pPr>
+              <a:spcBef>
+                <a:spcPts val="800"/>
               </a:spcBef>
               <a:defRPr sz="950">
                 <a:solidFill>
@@ -4023,11 +4023,11 @@
               </a:defRPr>
             </a:pPr>
             <a:r>
-              <a:t>• Lanzamiento nacional de Portabilidad Express eSIM.</a:t>
+              <a:t>• Lanzamiento de Portabilidad Express eSIM.</a:t>
             </a:r>
             <a:br/>
             <a:r>
-              <a:t>• Integración de Carrier Billing para streaming y LVBP.</a:t>
+              <a:t>• Acompañamiento a Tours Movilnet nacionales.</a:t>
             </a:r>
             <a:br/>
             <a:r>
@@ -4044,18 +4044,18 @@
         </p:nvSpPr>
         <p:spPr>
           <a:xfrm>
-            <a:off x="731520" y="4937760"/>
-            <a:ext cx="10698480" cy="1280160"/>
+            <a:off x="731520" y="4846320"/>
+            <a:ext cx="10698480" cy="1371600"/>
           </a:xfrm>
           <a:prstGeom prst="roundRect">
             <a:avLst/>
           </a:prstGeom>
           <a:solidFill>
-            <a:srgbClr val="1E1428"/>
+            <a:srgbClr val="064E3B"/>
           </a:solidFill>
           <a:ln>
             <a:solidFill>
-              <a:srgbClr val="E62020"/>
+              <a:srgbClr val="10B981"/>
             </a:solidFill>
           </a:ln>
         </p:spPr>
@@ -4074,7 +4074,7 @@
           </a:fontRef>
         </p:style>
         <p:txBody>
-          <a:bodyPr rtlCol="0" anchor="ctr" wrap="square" tIns="164592" lIns="274320"/>
+          <a:bodyPr rtlCol="0" anchor="ctr" wrap="square" tIns="137160" lIns="274320"/>
           <a:lstStyle/>
           <a:p>
             <a:pPr algn="ctr">
@@ -4085,7 +4085,7 @@
               </a:defRPr>
             </a:pPr>
             <a:r>
-              <a:t>🎯 CONCLUSIÓN CONJUNTA: UN PROYECTO GANADOR PARA MERCADEO Y FINANZAS</a:t>
+              <a:t>🎯 MECANISMO WATERFALL DE RETORNO Y GANANCIA DEL INVERSIONISTA</a:t>
             </a:r>
           </a:p>
           <a:p>
@@ -4095,12 +4095,27 @@
               </a:spcBef>
               <a:defRPr sz="1000">
                 <a:solidFill>
-                  <a:srgbClr val="CBD5E1"/>
-                </a:solidFill>
-              </a:defRPr>
-            </a:pPr>
-            <a:r>
-              <a:t>Para Finanzas: Payback menor a 8 meses, TIR del 68.4% y ahorro masivo de OPEX.  |  Para Mercadeo: +$1.29M en ingresos Año 1, ARPU de +43.5% y 120k nuevos clientes.</a:t>
+                  <a:srgbClr val="D1FAE5"/>
+                </a:solidFill>
+              </a:defRPr>
+            </a:pPr>
+            <a:r>
+              <a:t>• Fase 1 (Amortización Acelerada): El Inversor retiene el 75% del flujo neto hasta recuperar los $450k + 20% preferente. Payback en 6.2 Meses.</a:t>
+            </a:r>
+          </a:p>
+          <a:p>
+            <a:pPr>
+              <a:spcBef>
+                <a:spcPts val="300"/>
+              </a:spcBef>
+              <a:defRPr sz="1000">
+                <a:solidFill>
+                  <a:srgbClr val="D1FAE5"/>
+                </a:solidFill>
+              </a:defRPr>
+            </a:pPr>
+            <a:r>
+              <a:t>• Fase 2 (Utilidad Recurrente Compartida): Split 50% Inversor / 50% Movilnet. Flujo acumulado a 36 meses: $4.25M USD (ROI 9.4x).</a:t>
             </a:r>
           </a:p>
         </p:txBody>
@@ -4231,6 +4246,973 @@
               </a:defRPr>
             </a:pPr>
             <a:r>
+              <a:t>ESTRUCTURA DEL NEGOCIO</a:t>
+            </a:r>
+          </a:p>
+          <a:p>
+            <a:pPr>
+              <a:spcBef>
+                <a:spcPts val="300"/>
+              </a:spcBef>
+              <a:defRPr sz="2200" b="1">
+                <a:solidFill>
+                  <a:srgbClr val="FFFFFF"/>
+                </a:solidFill>
+              </a:defRPr>
+            </a:pPr>
+            <a:r>
+              <a:t>El Modelo de Alianza: Simetría de Aportes entre las Partes</a:t>
+            </a:r>
+          </a:p>
+          <a:p>
+            <a:pPr>
+              <a:spcBef>
+                <a:spcPts val="200"/>
+              </a:spcBef>
+              <a:defRPr sz="1100">
+                <a:solidFill>
+                  <a:srgbClr val="94A3B8"/>
+                </a:solidFill>
+              </a:defRPr>
+            </a:pPr>
+            <a:r>
+              <a:t>Movilnet no desembolsa fondos líquidos; aporta audiencia masiva y marketing nacional. El capital privado aporta tecnología.</a:t>
+            </a:r>
+          </a:p>
+        </p:txBody>
+      </p:sp>
+      <p:sp>
+        <p:nvSpPr>
+          <p:cNvPr id="4" name="Rounded Rectangle 3"/>
+          <p:cNvSpPr/>
+          <p:nvPr/>
+        </p:nvSpPr>
+        <p:spPr>
+          <a:xfrm>
+            <a:off x="731520" y="1645920"/>
+            <a:ext cx="5120640" cy="4480560"/>
+          </a:xfrm>
+          <a:prstGeom prst="roundRect">
+            <a:avLst/>
+          </a:prstGeom>
+          <a:solidFill>
+            <a:srgbClr val="121E3A"/>
+          </a:solidFill>
+          <a:ln>
+            <a:solidFill>
+              <a:srgbClr val="E62020"/>
+            </a:solidFill>
+          </a:ln>
+        </p:spPr>
+        <p:style>
+          <a:lnRef idx="1">
+            <a:schemeClr val="accent1"/>
+          </a:lnRef>
+          <a:fillRef idx="3">
+            <a:schemeClr val="accent1"/>
+          </a:fillRef>
+          <a:effectRef idx="2">
+            <a:schemeClr val="accent1"/>
+          </a:effectRef>
+          <a:fontRef idx="minor">
+            <a:schemeClr val="lt1"/>
+          </a:fontRef>
+        </p:style>
+        <p:txBody>
+          <a:bodyPr rtlCol="0" anchor="ctr" wrap="square" tIns="228600" lIns="274320"/>
+          <a:lstStyle/>
+          <a:p>
+            <a:pPr algn="ctr">
+              <a:defRPr sz="1150" b="1">
+                <a:solidFill>
+                  <a:srgbClr val="E62020"/>
+                </a:solidFill>
+              </a:defRPr>
+            </a:pPr>
+            <a:r>
+              <a:t>🏢 APORTE ESTRATÉGICO DE MOVILNET (CERO FONDOS LÍQUIDOS)</a:t>
+            </a:r>
+          </a:p>
+          <a:p>
+            <a:pPr>
+              <a:spcBef>
+                <a:spcPts val="700"/>
+              </a:spcBef>
+              <a:defRPr sz="950">
+                <a:solidFill>
+                  <a:srgbClr val="CBD5E1"/>
+                </a:solidFill>
+              </a:defRPr>
+            </a:pPr>
+            <a:r>
+              <a:t>• Base Cautiva de 4.2M Usuarios: Acceso exclusivo e inmediato a 4.2 millones de abonados activos sin costo de adquisición (CAC = $0).</a:t>
+            </a:r>
+          </a:p>
+          <a:p>
+            <a:pPr>
+              <a:spcBef>
+                <a:spcPts val="700"/>
+              </a:spcBef>
+              <a:defRPr sz="950">
+                <a:solidFill>
+                  <a:srgbClr val="CBD5E1"/>
+                </a:solidFill>
+              </a:defRPr>
+            </a:pPr>
+            <a:r>
+              <a:t>• Material POP Nacional: Producción y montaje de banderines, pendones, tótems y habladores en oficinas y agentes autorizados.</a:t>
+            </a:r>
+          </a:p>
+          <a:p>
+            <a:pPr>
+              <a:spcBef>
+                <a:spcPts val="700"/>
+              </a:spcBef>
+              <a:defRPr sz="950">
+                <a:solidFill>
+                  <a:srgbClr val="CBD5E1"/>
+                </a:solidFill>
+              </a:defRPr>
+            </a:pPr>
+            <a:r>
+              <a:t>• Presencia Física en Tours y Ferias: Inclusión obligatoria en Tours Movilnet regionales/municipales, seminarios, charlas y eventos cubiertos 100% por Movilnet.</a:t>
+            </a:r>
+          </a:p>
+          <a:p>
+            <a:pPr>
+              <a:spcBef>
+                <a:spcPts val="700"/>
+              </a:spcBef>
+              <a:defRPr sz="950">
+                <a:solidFill>
+                  <a:srgbClr val="CBD5E1"/>
+                </a:solidFill>
+              </a:defRPr>
+            </a:pPr>
+            <a:r>
+              <a:t>• Ecosistema Digital Oficial: Difusión masiva en redes oficiales (Instagram, TikTok, X), portal web movilnet.com.ve y SMS institucionales.</a:t>
+            </a:r>
+          </a:p>
+          <a:p>
+            <a:pPr>
+              <a:spcBef>
+                <a:spcPts val="700"/>
+              </a:spcBef>
+              <a:defRPr sz="950">
+                <a:solidFill>
+                  <a:srgbClr val="CBD5E1"/>
+                </a:solidFill>
+              </a:defRPr>
+            </a:pPr>
+            <a:r>
+              <a:t>• Protagonismo Institucional: MOVI como protagonista e imagen oficial de la compañía.</a:t>
+            </a:r>
+          </a:p>
+        </p:txBody>
+      </p:sp>
+      <p:sp>
+        <p:nvSpPr>
+          <p:cNvPr id="5" name="Rounded Rectangle 4"/>
+          <p:cNvSpPr/>
+          <p:nvPr/>
+        </p:nvSpPr>
+        <p:spPr>
+          <a:xfrm>
+            <a:off x="6217920" y="1645920"/>
+            <a:ext cx="5212080" cy="4480560"/>
+          </a:xfrm>
+          <a:prstGeom prst="roundRect">
+            <a:avLst/>
+          </a:prstGeom>
+          <a:solidFill>
+            <a:srgbClr val="121E3A"/>
+          </a:solidFill>
+          <a:ln>
+            <a:solidFill>
+              <a:srgbClr val="10B981"/>
+            </a:solidFill>
+          </a:ln>
+        </p:spPr>
+        <p:style>
+          <a:lnRef idx="1">
+            <a:schemeClr val="accent1"/>
+          </a:lnRef>
+          <a:fillRef idx="3">
+            <a:schemeClr val="accent1"/>
+          </a:fillRef>
+          <a:effectRef idx="2">
+            <a:schemeClr val="accent1"/>
+          </a:effectRef>
+          <a:fontRef idx="minor">
+            <a:schemeClr val="lt1"/>
+          </a:fontRef>
+        </p:style>
+        <p:txBody>
+          <a:bodyPr rtlCol="0" anchor="ctr" wrap="square" tIns="228600" lIns="274320"/>
+          <a:lstStyle/>
+          <a:p>
+            <a:pPr algn="ctr">
+              <a:defRPr sz="1150" b="1">
+                <a:solidFill>
+                  <a:srgbClr val="10B981"/>
+                </a:solidFill>
+              </a:defRPr>
+            </a:pPr>
+            <a:r>
+              <a:t>💼 APORTE DEL INVERSIONISTA PRIVADO (CAPITAL TECNOLÓGICO)</a:t>
+            </a:r>
+          </a:p>
+          <a:p>
+            <a:pPr>
+              <a:spcBef>
+                <a:spcPts val="700"/>
+              </a:spcBef>
+              <a:defRPr sz="950">
+                <a:solidFill>
+                  <a:srgbClr val="CBD5E1"/>
+                </a:solidFill>
+              </a:defRPr>
+            </a:pPr>
+            <a:r>
+              <a:t>• Financiamiento Tecnológico Total: Aporte de USD $450.000 para cómputo elástico en la nube, clúster de servidores de alta concurrencia y edge CDN.</a:t>
+            </a:r>
+          </a:p>
+          <a:p>
+            <a:pPr>
+              <a:spcBef>
+                <a:spcPts val="700"/>
+              </a:spcBef>
+              <a:defRPr sz="950">
+                <a:solidFill>
+                  <a:srgbClr val="CBD5E1"/>
+                </a:solidFill>
+              </a:defRPr>
+            </a:pPr>
+            <a:r>
+              <a:t>• Inferencia de IA y Modelos LLM: Integración de Google Gemini 2.5 Flash Multimodal para visión bancaria OCR y transcripción de voz.</a:t>
+            </a:r>
+          </a:p>
+          <a:p>
+            <a:pPr>
+              <a:spcBef>
+                <a:spcPts val="700"/>
+              </a:spcBef>
+              <a:defRPr sz="950">
+                <a:solidFill>
+                  <a:srgbClr val="CBD5E1"/>
+                </a:solidFill>
+              </a:defRPr>
+            </a:pPr>
+            <a:r>
+              <a:t>• Pasarela FinTech SUDEBAN C2P: Conectores interbancarios en tiempo real para liquidación de cobros en 12 segundos.</a:t>
+            </a:r>
+          </a:p>
+          <a:p>
+            <a:pPr>
+              <a:spcBef>
+                <a:spcPts val="700"/>
+              </a:spcBef>
+              <a:defRPr sz="950">
+                <a:solidFill>
+                  <a:srgbClr val="CBD5E1"/>
+                </a:solidFill>
+              </a:defRPr>
+            </a:pPr>
+            <a:r>
+              <a:t>• Ingeniería SRE 24/7 &amp; Seguridad: Blindaje criptográfico SHA-256, Zero-PII, SLA 99.95% y mantenimiento operativo continuo.</a:t>
+            </a:r>
+          </a:p>
+          <a:p>
+            <a:pPr>
+              <a:spcBef>
+                <a:spcPts val="700"/>
+              </a:spcBef>
+              <a:defRPr sz="950">
+                <a:solidFill>
+                  <a:srgbClr val="CBD5E1"/>
+                </a:solidFill>
+              </a:defRPr>
+            </a:pPr>
+            <a:r>
+              <a:t>• Esquema de Retorno Acelerado: Retiene el 75% del flujo de nuevos ingresos hasta recuperar el 100% de la inversión (Payback en 6.2 meses).</a:t>
+            </a:r>
+          </a:p>
+        </p:txBody>
+      </p:sp>
+      <p:sp>
+        <p:nvSpPr>
+          <p:cNvPr id="6" name="TextBox 5"/>
+          <p:cNvSpPr txBox="1"/>
+          <p:nvPr/>
+        </p:nvSpPr>
+        <p:spPr>
+          <a:xfrm>
+            <a:off x="731520" y="6446520"/>
+            <a:ext cx="10698480" cy="320040"/>
+          </a:xfrm>
+          <a:prstGeom prst="rect">
+            <a:avLst/>
+          </a:prstGeom>
+          <a:noFill/>
+        </p:spPr>
+        <p:txBody>
+          <a:bodyPr wrap="none" lIns="0" tIns="0" rIns="0" bIns="0">
+            <a:spAutoFit/>
+          </a:bodyPr>
+          <a:lstStyle/>
+          <a:p>
+            <a:pPr>
+              <a:defRPr sz="850">
+                <a:solidFill>
+                  <a:srgbClr val="94A3B8"/>
+                </a:solidFill>
+              </a:defRPr>
+            </a:pPr>
+            <a:r>
+              <a:t>🌐 Portal PWA 4GMAX: https://one21026-ids-movilnet-pwa-bxmz.onrender.com/ui/pwa_stitch/index.html  |  Telecomunicaciones Movilnet C.A.</a:t>
+            </a:r>
+          </a:p>
+        </p:txBody>
+      </p:sp>
+    </p:spTree>
+  </p:cSld>
+  <p:clrMapOvr>
+    <a:masterClrMapping/>
+  </p:clrMapOvr>
+</p:sld>
+</file>
+
+<file path=ppt/slides/slide3.xml><?xml version="1.0" encoding="utf-8"?>
+<p:sld xmlns:a="http://schemas.openxmlformats.org/drawingml/2006/main" xmlns:p="http://schemas.openxmlformats.org/presentationml/2006/main" xmlns:r="http://schemas.openxmlformats.org/officeDocument/2006/relationships">
+  <p:cSld>
+    <p:spTree>
+      <p:nvGrpSpPr>
+        <p:cNvPr id="1" name=""/>
+        <p:cNvGrpSpPr/>
+        <p:nvPr/>
+      </p:nvGrpSpPr>
+      <p:grpSpPr/>
+      <p:sp>
+        <p:nvSpPr>
+          <p:cNvPr id="2" name="Rectangle 1"/>
+          <p:cNvSpPr/>
+          <p:nvPr/>
+        </p:nvSpPr>
+        <p:spPr>
+          <a:xfrm>
+            <a:off x="0" y="0"/>
+            <a:ext cx="12191695" cy="6858000"/>
+          </a:xfrm>
+          <a:prstGeom prst="rect">
+            <a:avLst/>
+          </a:prstGeom>
+          <a:solidFill>
+            <a:srgbClr val="0B132B"/>
+          </a:solidFill>
+          <a:ln>
+            <a:noFill/>
+          </a:ln>
+        </p:spPr>
+        <p:style>
+          <a:lnRef idx="1">
+            <a:schemeClr val="accent1"/>
+          </a:lnRef>
+          <a:fillRef idx="3">
+            <a:schemeClr val="accent1"/>
+          </a:fillRef>
+          <a:effectRef idx="2">
+            <a:schemeClr val="accent1"/>
+          </a:effectRef>
+          <a:fontRef idx="minor">
+            <a:schemeClr val="lt1"/>
+          </a:fontRef>
+        </p:style>
+        <p:txBody>
+          <a:bodyPr rtlCol="0" anchor="ctr"/>
+          <a:lstStyle/>
+          <a:p>
+            <a:pPr algn="ctr"/>
+          </a:p>
+        </p:txBody>
+      </p:sp>
+      <p:sp>
+        <p:nvSpPr>
+          <p:cNvPr id="3" name="TextBox 2"/>
+          <p:cNvSpPr txBox="1"/>
+          <p:nvPr/>
+        </p:nvSpPr>
+        <p:spPr>
+          <a:xfrm>
+            <a:off x="731520" y="365760"/>
+            <a:ext cx="10698480" cy="1005840"/>
+          </a:xfrm>
+          <a:prstGeom prst="rect">
+            <a:avLst/>
+          </a:prstGeom>
+          <a:noFill/>
+        </p:spPr>
+        <p:txBody>
+          <a:bodyPr wrap="square" lIns="0" tIns="0" rIns="0" bIns="0">
+            <a:spAutoFit/>
+          </a:bodyPr>
+          <a:lstStyle/>
+          <a:p>
+            <a:pPr>
+              <a:defRPr sz="1000" b="1">
+                <a:solidFill>
+                  <a:srgbClr val="E62020"/>
+                </a:solidFill>
+              </a:defRPr>
+            </a:pPr>
+            <a:r>
+              <a:t>ESTRATEGIA DE MERCADEO</a:t>
+            </a:r>
+          </a:p>
+          <a:p>
+            <a:pPr>
+              <a:spcBef>
+                <a:spcPts val="300"/>
+              </a:spcBef>
+              <a:defRPr sz="2200" b="1">
+                <a:solidFill>
+                  <a:srgbClr val="FFFFFF"/>
+                </a:solidFill>
+              </a:defRPr>
+            </a:pPr>
+            <a:r>
+              <a:t>MOVI: El Protagonista Principal en Calles, Eventos y Medios</a:t>
+            </a:r>
+          </a:p>
+          <a:p>
+            <a:pPr>
+              <a:spcBef>
+                <a:spcPts val="200"/>
+              </a:spcBef>
+              <a:defRPr sz="1100">
+                <a:solidFill>
+                  <a:srgbClr val="94A3B8"/>
+                </a:solidFill>
+              </a:defRPr>
+            </a:pPr>
+            <a:r>
+              <a:t>Despliegue integral cubierto y financiado 100% por el presupuesto habitual de Mercadeo de Movilnet.</a:t>
+            </a:r>
+          </a:p>
+        </p:txBody>
+      </p:sp>
+      <p:sp>
+        <p:nvSpPr>
+          <p:cNvPr id="4" name="Rounded Rectangle 3"/>
+          <p:cNvSpPr/>
+          <p:nvPr/>
+        </p:nvSpPr>
+        <p:spPr>
+          <a:xfrm>
+            <a:off x="731520" y="1645920"/>
+            <a:ext cx="3429000" cy="4480560"/>
+          </a:xfrm>
+          <a:prstGeom prst="roundRect">
+            <a:avLst/>
+          </a:prstGeom>
+          <a:solidFill>
+            <a:srgbClr val="121E3A"/>
+          </a:solidFill>
+          <a:ln>
+            <a:solidFill>
+              <a:srgbClr val="1E3A64"/>
+            </a:solidFill>
+          </a:ln>
+        </p:spPr>
+        <p:style>
+          <a:lnRef idx="1">
+            <a:schemeClr val="accent1"/>
+          </a:lnRef>
+          <a:fillRef idx="3">
+            <a:schemeClr val="accent1"/>
+          </a:fillRef>
+          <a:effectRef idx="2">
+            <a:schemeClr val="accent1"/>
+          </a:effectRef>
+          <a:fontRef idx="minor">
+            <a:schemeClr val="lt1"/>
+          </a:fontRef>
+        </p:style>
+        <p:txBody>
+          <a:bodyPr rtlCol="0" anchor="ctr" wrap="square" tIns="182880" lIns="201168"/>
+          <a:lstStyle/>
+          <a:p>
+            <a:pPr algn="ctr">
+              <a:defRPr sz="1150" b="1">
+                <a:solidFill>
+                  <a:srgbClr val="E62020"/>
+                </a:solidFill>
+              </a:defRPr>
+            </a:pPr>
+            <a:r>
+              <a:t>1. Material POP &amp; Puntos de Venta</a:t>
+            </a:r>
+          </a:p>
+          <a:p>
+            <a:pPr>
+              <a:spcBef>
+                <a:spcPts val="300"/>
+              </a:spcBef>
+              <a:defRPr sz="1400" b="1">
+                <a:solidFill>
+                  <a:srgbClr val="FFFFFF"/>
+                </a:solidFill>
+              </a:defRPr>
+            </a:pPr>
+            <a:r>
+              <a:t>Presencia en Cada Tienda</a:t>
+            </a:r>
+          </a:p>
+          <a:p>
+            <a:pPr>
+              <a:spcBef>
+                <a:spcPts val="900"/>
+              </a:spcBef>
+              <a:defRPr sz="950">
+                <a:solidFill>
+                  <a:srgbClr val="CBD5E1"/>
+                </a:solidFill>
+              </a:defRPr>
+            </a:pPr>
+            <a:r>
+              <a:t>• Banderines oficiales MOVI en agentes comerciales.</a:t>
+            </a:r>
+          </a:p>
+          <a:p>
+            <a:pPr>
+              <a:spcBef>
+                <a:spcPts val="900"/>
+              </a:spcBef>
+              <a:defRPr sz="950">
+                <a:solidFill>
+                  <a:srgbClr val="CBD5E1"/>
+                </a:solidFill>
+              </a:defRPr>
+            </a:pPr>
+            <a:r>
+              <a:t>• Pendones de alto impacto: 'Recarga en 12s por WhatsApp'.</a:t>
+            </a:r>
+          </a:p>
+          <a:p>
+            <a:pPr>
+              <a:spcBef>
+                <a:spcPts val="900"/>
+              </a:spcBef>
+              <a:defRPr sz="950">
+                <a:solidFill>
+                  <a:srgbClr val="CBD5E1"/>
+                </a:solidFill>
+              </a:defRPr>
+            </a:pPr>
+            <a:r>
+              <a:t>• Habladores en taquillas con QR dinámico para autogestión.</a:t>
+            </a:r>
+          </a:p>
+          <a:p>
+            <a:pPr>
+              <a:spcBef>
+                <a:spcPts val="900"/>
+              </a:spcBef>
+              <a:defRPr sz="950">
+                <a:solidFill>
+                  <a:srgbClr val="CBD5E1"/>
+                </a:solidFill>
+              </a:defRPr>
+            </a:pPr>
+            <a:r>
+              <a:t>• Tótems interactivos en centros comerciales del país.</a:t>
+            </a:r>
+          </a:p>
+        </p:txBody>
+      </p:sp>
+      <p:sp>
+        <p:nvSpPr>
+          <p:cNvPr id="5" name="Rounded Rectangle 4"/>
+          <p:cNvSpPr/>
+          <p:nvPr/>
+        </p:nvSpPr>
+        <p:spPr>
+          <a:xfrm>
+            <a:off x="4343400" y="1645920"/>
+            <a:ext cx="3429000" cy="4480560"/>
+          </a:xfrm>
+          <a:prstGeom prst="roundRect">
+            <a:avLst/>
+          </a:prstGeom>
+          <a:solidFill>
+            <a:srgbClr val="121E3A"/>
+          </a:solidFill>
+          <a:ln>
+            <a:solidFill>
+              <a:srgbClr val="1E3A64"/>
+            </a:solidFill>
+          </a:ln>
+        </p:spPr>
+        <p:style>
+          <a:lnRef idx="1">
+            <a:schemeClr val="accent1"/>
+          </a:lnRef>
+          <a:fillRef idx="3">
+            <a:schemeClr val="accent1"/>
+          </a:fillRef>
+          <a:effectRef idx="2">
+            <a:schemeClr val="accent1"/>
+          </a:effectRef>
+          <a:fontRef idx="minor">
+            <a:schemeClr val="lt1"/>
+          </a:fontRef>
+        </p:style>
+        <p:txBody>
+          <a:bodyPr rtlCol="0" anchor="ctr" wrap="square" tIns="182880" lIns="201168"/>
+          <a:lstStyle/>
+          <a:p>
+            <a:pPr algn="ctr">
+              <a:defRPr sz="1150" b="1">
+                <a:solidFill>
+                  <a:srgbClr val="F59E0B"/>
+                </a:solidFill>
+              </a:defRPr>
+            </a:pPr>
+            <a:r>
+              <a:t>2. Tours Movilnet Nacionales</a:t>
+            </a:r>
+          </a:p>
+          <a:p>
+            <a:pPr>
+              <a:spcBef>
+                <a:spcPts val="300"/>
+              </a:spcBef>
+              <a:defRPr sz="1400" b="1">
+                <a:solidFill>
+                  <a:srgbClr val="FFFFFF"/>
+                </a:solidFill>
+              </a:defRPr>
+            </a:pPr>
+            <a:r>
+              <a:t>Caravanas en Regiones y Plazas</a:t>
+            </a:r>
+          </a:p>
+          <a:p>
+            <a:pPr>
+              <a:spcBef>
+                <a:spcPts val="900"/>
+              </a:spcBef>
+              <a:defRPr sz="950">
+                <a:solidFill>
+                  <a:srgbClr val="CBD5E1"/>
+                </a:solidFill>
+              </a:defRPr>
+            </a:pPr>
+            <a:r>
+              <a:t>• Presencia en charlas, conferencias, seminarios y ferias.</a:t>
+            </a:r>
+          </a:p>
+          <a:p>
+            <a:pPr>
+              <a:spcBef>
+                <a:spcPts val="900"/>
+              </a:spcBef>
+              <a:defRPr sz="950">
+                <a:solidFill>
+                  <a:srgbClr val="CBD5E1"/>
+                </a:solidFill>
+              </a:defRPr>
+            </a:pPr>
+            <a:r>
+              <a:t>• Activaciones en vivo: recarga y consulta en tarima pública.</a:t>
+            </a:r>
+          </a:p>
+          <a:p>
+            <a:pPr>
+              <a:spcBef>
+                <a:spcPts val="900"/>
+              </a:spcBef>
+              <a:defRPr sz="950">
+                <a:solidFill>
+                  <a:srgbClr val="CBD5E1"/>
+                </a:solidFill>
+              </a:defRPr>
+            </a:pPr>
+            <a:r>
+              <a:t>• Trivias gamificadas conducidas por la IA en WhatsApp.</a:t>
+            </a:r>
+          </a:p>
+          <a:p>
+            <a:pPr>
+              <a:spcBef>
+                <a:spcPts val="900"/>
+              </a:spcBef>
+              <a:defRPr sz="950">
+                <a:solidFill>
+                  <a:srgbClr val="CBD5E1"/>
+                </a:solidFill>
+              </a:defRPr>
+            </a:pPr>
+            <a:r>
+              <a:t>• Cobertura logística y viáticos 100% pagados por Movilnet.</a:t>
+            </a:r>
+          </a:p>
+        </p:txBody>
+      </p:sp>
+      <p:sp>
+        <p:nvSpPr>
+          <p:cNvPr id="6" name="Rounded Rectangle 5"/>
+          <p:cNvSpPr/>
+          <p:nvPr/>
+        </p:nvSpPr>
+        <p:spPr>
+          <a:xfrm>
+            <a:off x="7955280" y="1645920"/>
+            <a:ext cx="3429000" cy="4480560"/>
+          </a:xfrm>
+          <a:prstGeom prst="roundRect">
+            <a:avLst/>
+          </a:prstGeom>
+          <a:solidFill>
+            <a:srgbClr val="121E3A"/>
+          </a:solidFill>
+          <a:ln>
+            <a:solidFill>
+              <a:srgbClr val="1E3A64"/>
+            </a:solidFill>
+          </a:ln>
+        </p:spPr>
+        <p:style>
+          <a:lnRef idx="1">
+            <a:schemeClr val="accent1"/>
+          </a:lnRef>
+          <a:fillRef idx="3">
+            <a:schemeClr val="accent1"/>
+          </a:fillRef>
+          <a:effectRef idx="2">
+            <a:schemeClr val="accent1"/>
+          </a:effectRef>
+          <a:fontRef idx="minor">
+            <a:schemeClr val="lt1"/>
+          </a:fontRef>
+        </p:style>
+        <p:txBody>
+          <a:bodyPr rtlCol="0" anchor="ctr" wrap="square" tIns="182880" lIns="201168"/>
+          <a:lstStyle/>
+          <a:p>
+            <a:pPr algn="ctr">
+              <a:defRPr sz="1150" b="1">
+                <a:solidFill>
+                  <a:srgbClr val="0EA5E9"/>
+                </a:solidFill>
+              </a:defRPr>
+            </a:pPr>
+            <a:r>
+              <a:t>3. Ecosistema Digital &amp; Web</a:t>
+            </a:r>
+          </a:p>
+          <a:p>
+            <a:pPr>
+              <a:spcBef>
+                <a:spcPts val="300"/>
+              </a:spcBef>
+              <a:defRPr sz="1400" b="1">
+                <a:solidFill>
+                  <a:srgbClr val="FFFFFF"/>
+                </a:solidFill>
+              </a:defRPr>
+            </a:pPr>
+            <a:r>
+              <a:t>Redes Sociales y Masivos</a:t>
+            </a:r>
+          </a:p>
+          <a:p>
+            <a:pPr>
+              <a:spcBef>
+                <a:spcPts val="900"/>
+              </a:spcBef>
+              <a:defRPr sz="950">
+                <a:solidFill>
+                  <a:srgbClr val="CBD5E1"/>
+                </a:solidFill>
+              </a:defRPr>
+            </a:pPr>
+            <a:r>
+              <a:t>• Hero Banner principal en www.movilnet.com.ve.</a:t>
+            </a:r>
+          </a:p>
+          <a:p>
+            <a:pPr>
+              <a:spcBef>
+                <a:spcPts val="900"/>
+              </a:spcBef>
+              <a:defRPr sz="950">
+                <a:solidFill>
+                  <a:srgbClr val="CBD5E1"/>
+                </a:solidFill>
+              </a:defRPr>
+            </a:pPr>
+            <a:r>
+              <a:t>• Campaña viral en Instagram, TikTok, X y Facebook.</a:t>
+            </a:r>
+          </a:p>
+          <a:p>
+            <a:pPr>
+              <a:spcBef>
+                <a:spcPts val="900"/>
+              </a:spcBef>
+              <a:defRPr sz="950">
+                <a:solidFill>
+                  <a:srgbClr val="CBD5E1"/>
+                </a:solidFill>
+              </a:defRPr>
+            </a:pPr>
+            <a:r>
+              <a:t>• SMS push institucionales dirigidos a los 4.2M de usuarios.</a:t>
+            </a:r>
+          </a:p>
+          <a:p>
+            <a:pPr>
+              <a:spcBef>
+                <a:spcPts val="900"/>
+              </a:spcBef>
+              <a:defRPr sz="950">
+                <a:solidFill>
+                  <a:srgbClr val="CBD5E1"/>
+                </a:solidFill>
+              </a:defRPr>
+            </a:pPr>
+            <a:r>
+              <a:t>• Bono Freemium de 1.000 tokens para captar a la competencia.</a:t>
+            </a:r>
+          </a:p>
+        </p:txBody>
+      </p:sp>
+      <p:sp>
+        <p:nvSpPr>
+          <p:cNvPr id="7" name="TextBox 6"/>
+          <p:cNvSpPr txBox="1"/>
+          <p:nvPr/>
+        </p:nvSpPr>
+        <p:spPr>
+          <a:xfrm>
+            <a:off x="731520" y="6446520"/>
+            <a:ext cx="10698480" cy="320040"/>
+          </a:xfrm>
+          <a:prstGeom prst="rect">
+            <a:avLst/>
+          </a:prstGeom>
+          <a:noFill/>
+        </p:spPr>
+        <p:txBody>
+          <a:bodyPr wrap="none" lIns="0" tIns="0" rIns="0" bIns="0">
+            <a:spAutoFit/>
+          </a:bodyPr>
+          <a:lstStyle/>
+          <a:p>
+            <a:pPr>
+              <a:defRPr sz="850">
+                <a:solidFill>
+                  <a:srgbClr val="94A3B8"/>
+                </a:solidFill>
+              </a:defRPr>
+            </a:pPr>
+            <a:r>
+              <a:t>🌐 Portal PWA 4GMAX: https://one21026-ids-movilnet-pwa-bxmz.onrender.com/ui/pwa_stitch/index.html  |  Telecomunicaciones Movilnet C.A.</a:t>
+            </a:r>
+          </a:p>
+        </p:txBody>
+      </p:sp>
+    </p:spTree>
+  </p:cSld>
+  <p:clrMapOvr>
+    <a:masterClrMapping/>
+  </p:clrMapOvr>
+</p:sld>
+</file>
+
+<file path=ppt/slides/slide4.xml><?xml version="1.0" encoding="utf-8"?>
+<p:sld xmlns:a="http://schemas.openxmlformats.org/drawingml/2006/main" xmlns:p="http://schemas.openxmlformats.org/presentationml/2006/main" xmlns:r="http://schemas.openxmlformats.org/officeDocument/2006/relationships">
+  <p:cSld>
+    <p:spTree>
+      <p:nvGrpSpPr>
+        <p:cNvPr id="1" name=""/>
+        <p:cNvGrpSpPr/>
+        <p:nvPr/>
+      </p:nvGrpSpPr>
+      <p:grpSpPr/>
+      <p:sp>
+        <p:nvSpPr>
+          <p:cNvPr id="2" name="Rectangle 1"/>
+          <p:cNvSpPr/>
+          <p:nvPr/>
+        </p:nvSpPr>
+        <p:spPr>
+          <a:xfrm>
+            <a:off x="0" y="0"/>
+            <a:ext cx="12191695" cy="6858000"/>
+          </a:xfrm>
+          <a:prstGeom prst="rect">
+            <a:avLst/>
+          </a:prstGeom>
+          <a:solidFill>
+            <a:srgbClr val="0B132B"/>
+          </a:solidFill>
+          <a:ln>
+            <a:noFill/>
+          </a:ln>
+        </p:spPr>
+        <p:style>
+          <a:lnRef idx="1">
+            <a:schemeClr val="accent1"/>
+          </a:lnRef>
+          <a:fillRef idx="3">
+            <a:schemeClr val="accent1"/>
+          </a:fillRef>
+          <a:effectRef idx="2">
+            <a:schemeClr val="accent1"/>
+          </a:effectRef>
+          <a:fontRef idx="minor">
+            <a:schemeClr val="lt1"/>
+          </a:fontRef>
+        </p:style>
+        <p:txBody>
+          <a:bodyPr rtlCol="0" anchor="ctr"/>
+          <a:lstStyle/>
+          <a:p>
+            <a:pPr algn="ctr"/>
+          </a:p>
+        </p:txBody>
+      </p:sp>
+      <p:sp>
+        <p:nvSpPr>
+          <p:cNvPr id="3" name="TextBox 2"/>
+          <p:cNvSpPr txBox="1"/>
+          <p:nvPr/>
+        </p:nvSpPr>
+        <p:spPr>
+          <a:xfrm>
+            <a:off x="731520" y="365760"/>
+            <a:ext cx="10698480" cy="1005840"/>
+          </a:xfrm>
+          <a:prstGeom prst="rect">
+            <a:avLst/>
+          </a:prstGeom>
+          <a:noFill/>
+        </p:spPr>
+        <p:txBody>
+          <a:bodyPr wrap="square" lIns="0" tIns="0" rIns="0" bIns="0">
+            <a:spAutoFit/>
+          </a:bodyPr>
+          <a:lstStyle/>
+          <a:p>
+            <a:pPr>
+              <a:defRPr sz="1000" b="1">
+                <a:solidFill>
+                  <a:srgbClr val="E62020"/>
+                </a:solidFill>
+              </a:defRPr>
+            </a:pPr>
+            <a:r>
               <a:t>DIAGNÓSTICO DEL NEGOCIO TELCO</a:t>
             </a:r>
           </a:p>
@@ -4246,7 +5228,7 @@
               </a:defRPr>
             </a:pPr>
             <a:r>
-              <a:t>El Salto Cuántico: De Costo Lineal a Activo Productivo</a:t>
+              <a:t>El Salto Cuántico: De Pozo de OPEX a Activo de Nuevos Ingresos</a:t>
             </a:r>
           </a:p>
           <a:p>
@@ -4261,7 +5243,7 @@
               </a:defRPr>
             </a:pPr>
             <a:r>
-              <a:t>Comparativa económica entre el modelo de call center analógico y la plataforma autónoma MOVI.</a:t>
+              <a:t>Comparativa económica entre la atención humana tradicional y la plataforma autónoma MOVI.</a:t>
             </a:r>
           </a:p>
         </p:txBody>
@@ -4308,7 +5290,7 @@
           <a:lstStyle/>
           <a:p>
             <a:pPr algn="ctr">
-              <a:defRPr sz="1300" b="1">
+              <a:defRPr sz="1200" b="1">
                 <a:solidFill>
                   <a:srgbClr val="E62020"/>
                 </a:solidFill>
@@ -4323,7 +5305,7 @@
               <a:spcBef>
                 <a:spcPts val="1200"/>
               </a:spcBef>
-              <a:defRPr sz="1100">
+              <a:defRPr sz="1050">
                 <a:solidFill>
                   <a:srgbClr val="CBD5E1"/>
                 </a:solidFill>
@@ -4338,7 +5320,7 @@
               <a:spcBef>
                 <a:spcPts val="1000"/>
               </a:spcBef>
-              <a:defRPr sz="1100">
+              <a:defRPr sz="1050">
                 <a:solidFill>
                   <a:srgbClr val="CBD5E1"/>
                 </a:solidFill>
@@ -4353,7 +5335,7 @@
               <a:spcBef>
                 <a:spcPts val="1000"/>
               </a:spcBef>
-              <a:defRPr sz="1100">
+              <a:defRPr sz="1050">
                 <a:solidFill>
                   <a:srgbClr val="CBD5E1"/>
                 </a:solidFill>
@@ -4368,7 +5350,7 @@
               <a:spcBef>
                 <a:spcPts val="1000"/>
               </a:spcBef>
-              <a:defRPr sz="1100">
+              <a:defRPr sz="1050">
                 <a:solidFill>
                   <a:srgbClr val="CBD5E1"/>
                 </a:solidFill>
@@ -4422,7 +5404,7 @@
           <a:lstStyle/>
           <a:p>
             <a:pPr algn="ctr">
-              <a:defRPr sz="1300" b="1">
+              <a:defRPr sz="1200" b="1">
                 <a:solidFill>
                   <a:srgbClr val="10B981"/>
                 </a:solidFill>
@@ -4437,7 +5419,7 @@
               <a:spcBef>
                 <a:spcPts val="1200"/>
               </a:spcBef>
-              <a:defRPr sz="1100">
+              <a:defRPr sz="1050">
                 <a:solidFill>
                   <a:srgbClr val="CBD5E1"/>
                 </a:solidFill>
@@ -4452,7 +5434,7 @@
               <a:spcBef>
                 <a:spcPts val="1000"/>
               </a:spcBef>
-              <a:defRPr sz="1100">
+              <a:defRPr sz="1050">
                 <a:solidFill>
                   <a:srgbClr val="CBD5E1"/>
                 </a:solidFill>
@@ -4467,7 +5449,7 @@
               <a:spcBef>
                 <a:spcPts val="1000"/>
               </a:spcBef>
-              <a:defRPr sz="1100">
+              <a:defRPr sz="1050">
                 <a:solidFill>
                   <a:srgbClr val="CBD5E1"/>
                 </a:solidFill>
@@ -4482,14 +5464,14 @@
               <a:spcBef>
                 <a:spcPts val="1000"/>
               </a:spcBef>
-              <a:defRPr sz="1100">
+              <a:defRPr sz="1050">
                 <a:solidFill>
                   <a:srgbClr val="CBD5E1"/>
                 </a:solidFill>
               </a:defRPr>
             </a:pPr>
             <a:r>
-              <a:t>• Cross-Selling Automático: Venta de bolsas Extra Datos y cupones de retail al consultar saldo.</a:t>
+              <a:t>• Cross-Selling Automático: Venta de bolsas Extra Datos y cupones retail al consultar saldo.</a:t>
             </a:r>
           </a:p>
         </p:txBody>
@@ -4537,7 +5519,7 @@
 </p:sld>
 </file>
 
-<file path=ppt/slides/slide3.xml><?xml version="1.0" encoding="utf-8"?>
+<file path=ppt/slides/slide5.xml><?xml version="1.0" encoding="utf-8"?>
 <p:sld xmlns:a="http://schemas.openxmlformats.org/drawingml/2006/main" xmlns:p="http://schemas.openxmlformats.org/presentationml/2006/main" xmlns:r="http://schemas.openxmlformats.org/officeDocument/2006/relationships">
   <p:cSld>
     <p:spTree>
@@ -4697,7 +5679,7 @@
           <a:lstStyle/>
           <a:p>
             <a:pPr algn="ctr">
-              <a:defRPr sz="1300" b="1">
+              <a:defRPr sz="1200" b="1">
                 <a:solidFill>
                   <a:srgbClr val="FFFFFF"/>
                 </a:solidFill>
@@ -4719,7 +5701,7 @@
               </a:defRPr>
             </a:pPr>
             <a:r>
-              <a:t>$720k / Año 1</a:t>
+              <a:t>$840k / Año 1</a:t>
             </a:r>
           </a:p>
           <a:p>
@@ -4727,7 +5709,7 @@
               <a:spcBef>
                 <a:spcPts val="500"/>
               </a:spcBef>
-              <a:defRPr sz="1000">
+              <a:defRPr sz="950">
                 <a:solidFill>
                   <a:srgbClr val="CBD5E1"/>
                 </a:solidFill>
@@ -4781,7 +5763,7 @@
           <a:lstStyle/>
           <a:p>
             <a:pPr algn="ctr">
-              <a:defRPr sz="1300" b="1">
+              <a:defRPr sz="1200" b="1">
                 <a:solidFill>
                   <a:srgbClr val="FFFFFF"/>
                 </a:solidFill>
@@ -4811,7 +5793,7 @@
               <a:spcBef>
                 <a:spcPts val="500"/>
               </a:spcBef>
-              <a:defRPr sz="1000">
+              <a:defRPr sz="950">
                 <a:solidFill>
                   <a:srgbClr val="CBD5E1"/>
                 </a:solidFill>
@@ -4865,7 +5847,7 @@
           <a:lstStyle/>
           <a:p>
             <a:pPr algn="ctr">
-              <a:defRPr sz="1300" b="1">
+              <a:defRPr sz="1200" b="1">
                 <a:solidFill>
                   <a:srgbClr val="FFFFFF"/>
                 </a:solidFill>
@@ -4887,7 +5869,7 @@
               </a:defRPr>
             </a:pPr>
             <a:r>
-              <a:t>$360k / Año 1</a:t>
+              <a:t>$420k / Año 1</a:t>
             </a:r>
           </a:p>
           <a:p>
@@ -4895,7 +5877,7 @@
               <a:spcBef>
                 <a:spcPts val="500"/>
               </a:spcBef>
-              <a:defRPr sz="1000">
+              <a:defRPr sz="950">
                 <a:solidFill>
                   <a:srgbClr val="CBD5E1"/>
                 </a:solidFill>
@@ -4949,7 +5931,7 @@
           <a:lstStyle/>
           <a:p>
             <a:pPr algn="ctr">
-              <a:defRPr sz="1300" b="1">
+              <a:defRPr sz="1200" b="1">
                 <a:solidFill>
                   <a:srgbClr val="FFFFFF"/>
                 </a:solidFill>
@@ -4979,7 +5961,7 @@
               <a:spcBef>
                 <a:spcPts val="500"/>
               </a:spcBef>
-              <a:defRPr sz="1000">
+              <a:defRPr sz="950">
                 <a:solidFill>
                   <a:srgbClr val="CBD5E1"/>
                 </a:solidFill>
@@ -5033,7 +6015,7 @@
           <a:lstStyle/>
           <a:p>
             <a:pPr algn="ctr">
-              <a:defRPr sz="1300" b="1">
+              <a:defRPr sz="1200" b="1">
                 <a:solidFill>
                   <a:srgbClr val="FFFFFF"/>
                 </a:solidFill>
@@ -5063,7 +6045,7 @@
               <a:spcBef>
                 <a:spcPts val="500"/>
               </a:spcBef>
-              <a:defRPr sz="1000">
+              <a:defRPr sz="950">
                 <a:solidFill>
                   <a:srgbClr val="CBD5E1"/>
                 </a:solidFill>
@@ -5118,7 +6100,7 @@
 </p:sld>
 </file>
 
-<file path=ppt/slides/slide4.xml><?xml version="1.0" encoding="utf-8"?>
+<file path=ppt/slides/slide6.xml><?xml version="1.0" encoding="utf-8"?>
 <p:sld xmlns:a="http://schemas.openxmlformats.org/drawingml/2006/main" xmlns:p="http://schemas.openxmlformats.org/presentationml/2006/main" xmlns:r="http://schemas.openxmlformats.org/officeDocument/2006/relationships">
   <p:cSld>
     <p:spTree>
@@ -5293,7 +6275,7 @@
               <a:spcBef>
                 <a:spcPts val="400"/>
               </a:spcBef>
-              <a:defRPr sz="1400" b="1">
+              <a:defRPr sz="1300" b="1">
                 <a:solidFill>
                   <a:srgbClr val="FFFFFF"/>
                 </a:solidFill>
@@ -5306,9 +6288,9 @@
           <a:p>
             <a:pPr>
               <a:spcBef>
-                <a:spcPts val="1400"/>
-              </a:spcBef>
-              <a:defRPr sz="1000" i="1">
+                <a:spcPts val="1200"/>
+              </a:spcBef>
+              <a:defRPr sz="950" i="1">
                 <a:solidFill>
                   <a:srgbClr val="E2E8F0"/>
                 </a:solidFill>
@@ -5321,9 +6303,9 @@
           <a:p>
             <a:pPr>
               <a:spcBef>
-                <a:spcPts val="1400"/>
-              </a:spcBef>
-              <a:defRPr sz="950">
+                <a:spcPts val="1200"/>
+              </a:spcBef>
+              <a:defRPr sz="900">
                 <a:solidFill>
                   <a:srgbClr val="94A3B8"/>
                 </a:solidFill>
@@ -5392,7 +6374,7 @@
               <a:spcBef>
                 <a:spcPts val="400"/>
               </a:spcBef>
-              <a:defRPr sz="1400" b="1">
+              <a:defRPr sz="1300" b="1">
                 <a:solidFill>
                   <a:srgbClr val="FFFFFF"/>
                 </a:solidFill>
@@ -5405,9 +6387,9 @@
           <a:p>
             <a:pPr>
               <a:spcBef>
-                <a:spcPts val="1400"/>
-              </a:spcBef>
-              <a:defRPr sz="1000" i="1">
+                <a:spcPts val="1200"/>
+              </a:spcBef>
+              <a:defRPr sz="950" i="1">
                 <a:solidFill>
                   <a:srgbClr val="E2E8F0"/>
                 </a:solidFill>
@@ -5420,9 +6402,9 @@
           <a:p>
             <a:pPr>
               <a:spcBef>
-                <a:spcPts val="1400"/>
-              </a:spcBef>
-              <a:defRPr sz="950">
+                <a:spcPts val="1200"/>
+              </a:spcBef>
+              <a:defRPr sz="900">
                 <a:solidFill>
                   <a:srgbClr val="94A3B8"/>
                 </a:solidFill>
@@ -5491,7 +6473,7 @@
               <a:spcBef>
                 <a:spcPts val="400"/>
               </a:spcBef>
-              <a:defRPr sz="1400" b="1">
+              <a:defRPr sz="1300" b="1">
                 <a:solidFill>
                   <a:srgbClr val="FFFFFF"/>
                 </a:solidFill>
@@ -5504,9 +6486,9 @@
           <a:p>
             <a:pPr>
               <a:spcBef>
-                <a:spcPts val="1400"/>
-              </a:spcBef>
-              <a:defRPr sz="1000" i="1">
+                <a:spcPts val="1200"/>
+              </a:spcBef>
+              <a:defRPr sz="950" i="1">
                 <a:solidFill>
                   <a:srgbClr val="E2E8F0"/>
                 </a:solidFill>
@@ -5519,9 +6501,9 @@
           <a:p>
             <a:pPr>
               <a:spcBef>
-                <a:spcPts val="1400"/>
-              </a:spcBef>
-              <a:defRPr sz="950">
+                <a:spcPts val="1200"/>
+              </a:spcBef>
+              <a:defRPr sz="900">
                 <a:solidFill>
                   <a:srgbClr val="94A3B8"/>
                 </a:solidFill>
@@ -5590,7 +6572,7 @@
               <a:spcBef>
                 <a:spcPts val="400"/>
               </a:spcBef>
-              <a:defRPr sz="1400" b="1">
+              <a:defRPr sz="1300" b="1">
                 <a:solidFill>
                   <a:srgbClr val="FFFFFF"/>
                 </a:solidFill>
@@ -5603,9 +6585,9 @@
           <a:p>
             <a:pPr>
               <a:spcBef>
-                <a:spcPts val="1400"/>
-              </a:spcBef>
-              <a:defRPr sz="1000" i="1">
+                <a:spcPts val="1200"/>
+              </a:spcBef>
+              <a:defRPr sz="950" i="1">
                 <a:solidFill>
                   <a:srgbClr val="E2E8F0"/>
                 </a:solidFill>
@@ -5618,9 +6600,9 @@
           <a:p>
             <a:pPr>
               <a:spcBef>
-                <a:spcPts val="1400"/>
-              </a:spcBef>
-              <a:defRPr sz="950">
+                <a:spcPts val="1200"/>
+              </a:spcBef>
+              <a:defRPr sz="900">
                 <a:solidFill>
                   <a:srgbClr val="94A3B8"/>
                 </a:solidFill>
@@ -5675,7 +6657,7 @@
 </p:sld>
 </file>
 
-<file path=ppt/slides/slide5.xml><?xml version="1.0" encoding="utf-8"?>
+<file path=ppt/slides/slide7.xml><?xml version="1.0" encoding="utf-8"?>
 <p:sld xmlns:a="http://schemas.openxmlformats.org/drawingml/2006/main" xmlns:p="http://schemas.openxmlformats.org/presentationml/2006/main" xmlns:r="http://schemas.openxmlformats.org/officeDocument/2006/relationships">
   <p:cSld>
     <p:spTree>
@@ -5835,7 +6817,7 @@
           <a:lstStyle/>
           <a:p>
             <a:pPr algn="ctr">
-              <a:defRPr sz="2200" b="1">
+              <a:defRPr sz="2100" b="1">
                 <a:solidFill>
                   <a:srgbClr val="E62020"/>
                 </a:solidFill>
@@ -5863,7 +6845,7 @@
           <a:p>
             <a:pPr>
               <a:spcBef>
-                <a:spcPts val="600"/>
+                <a:spcPts val="500"/>
               </a:spcBef>
               <a:defRPr sz="950">
                 <a:solidFill>
@@ -5919,7 +6901,7 @@
           <a:lstStyle/>
           <a:p>
             <a:pPr algn="ctr">
-              <a:defRPr sz="2200" b="1">
+              <a:defRPr sz="2100" b="1">
                 <a:solidFill>
                   <a:srgbClr val="F59E0B"/>
                 </a:solidFill>
@@ -5947,7 +6929,7 @@
           <a:p>
             <a:pPr>
               <a:spcBef>
-                <a:spcPts val="600"/>
+                <a:spcPts val="500"/>
               </a:spcBef>
               <a:defRPr sz="950">
                 <a:solidFill>
@@ -6003,7 +6985,7 @@
           <a:lstStyle/>
           <a:p>
             <a:pPr algn="ctr">
-              <a:defRPr sz="2200" b="1">
+              <a:defRPr sz="2100" b="1">
                 <a:solidFill>
                   <a:srgbClr val="10B981"/>
                 </a:solidFill>
@@ -6031,7 +7013,7 @@
           <a:p>
             <a:pPr>
               <a:spcBef>
-                <a:spcPts val="600"/>
+                <a:spcPts val="500"/>
               </a:spcBef>
               <a:defRPr sz="950">
                 <a:solidFill>
@@ -6083,11 +7065,11 @@
           </a:fontRef>
         </p:style>
         <p:txBody>
-          <a:bodyPr rtlCol="0" anchor="ctr" wrap="square" tIns="228600" lIns="274320"/>
+          <a:bodyPr rtlCol="0" anchor="ctr" wrap="square" tIns="201168" lIns="274320"/>
           <a:lstStyle/>
           <a:p>
             <a:pPr algn="ctr">
-              <a:defRPr sz="1300" b="1">
+              <a:defRPr sz="1200" b="1">
                 <a:solidFill>
                   <a:srgbClr val="0EA5E9"/>
                 </a:solidFill>
@@ -6100,46 +7082,46 @@
           <a:p>
             <a:pPr>
               <a:spcBef>
-                <a:spcPts val="800"/>
-              </a:spcBef>
-              <a:defRPr sz="1050">
+                <a:spcPts val="700"/>
+              </a:spcBef>
+              <a:defRPr sz="1000">
                 <a:solidFill>
                   <a:srgbClr val="CBD5E1"/>
                 </a:solidFill>
               </a:defRPr>
             </a:pPr>
             <a:r>
-              <a:t>1. Generación de Cupones TOTP (60 Segundos): Cada cupón contiene un código dinámico de un solo uso que expira en 60s, evitando duplicados o capturas de pantalla falsificadas en taquilla.</a:t>
-            </a:r>
-          </a:p>
-          <a:p>
-            <a:pPr>
-              <a:spcBef>
-                <a:spcPts val="600"/>
-              </a:spcBef>
-              <a:defRPr sz="1050">
+              <a:t>1. Generación de Cupones TOTP (60 Segundos): Código dinámico de un solo uso que expira en 60s, evitando capturas falsificadas en taquilla.</a:t>
+            </a:r>
+          </a:p>
+          <a:p>
+            <a:pPr>
+              <a:spcBef>
+                <a:spcPts val="500"/>
+              </a:spcBef>
+              <a:defRPr sz="1000">
                 <a:solidFill>
                   <a:srgbClr val="CBD5E1"/>
                 </a:solidFill>
               </a:defRPr>
             </a:pPr>
             <a:r>
-              <a:t>2. Liquidación Automática en Cero Inventario: Movilnet no compra ni almacena productos físicos. Solo cobra su comisión publicitaria al momento de la validación del consumo en el POS aliado.</a:t>
-            </a:r>
-          </a:p>
-          <a:p>
-            <a:pPr>
-              <a:spcBef>
-                <a:spcPts val="600"/>
-              </a:spcBef>
-              <a:defRPr sz="1050">
+              <a:t>2. Liquidación Automática en Cero Inventario: Movilnet no compra ni almacena inventario. Solo cobra comisión al validarse el consumo en el POS aliado.</a:t>
+            </a:r>
+          </a:p>
+          <a:p>
+            <a:pPr>
+              <a:spcBef>
+                <a:spcPts val="500"/>
+              </a:spcBef>
+              <a:defRPr sz="1000">
                 <a:solidFill>
                   <a:srgbClr val="10B981"/>
                 </a:solidFill>
               </a:defRPr>
             </a:pPr>
             <a:r>
-              <a:t>3. Margen Operativo Bruto &gt;85%: Al operar sobre infraestructura de software en la nube, el margen de ganancia de esta línea de ingresos no-tarifarios es casi puro beneficio.</a:t>
+              <a:t>3. Margen Operativo Bruto &gt;85%: Operación 100% sobre software en la nube, traduciéndose en beneficio neto directo.</a:t>
             </a:r>
           </a:p>
         </p:txBody>
@@ -6187,7 +7169,7 @@
 </p:sld>
 </file>
 
-<file path=ppt/slides/slide6.xml><?xml version="1.0" encoding="utf-8"?>
+<file path=ppt/slides/slide8.xml><?xml version="1.0" encoding="utf-8"?>
 <p:sld xmlns:a="http://schemas.openxmlformats.org/drawingml/2006/main" xmlns:p="http://schemas.openxmlformats.org/presentationml/2006/main" xmlns:r="http://schemas.openxmlformats.org/officeDocument/2006/relationships">
   <p:cSld>
     <p:spTree>
@@ -6270,7 +7252,7 @@
               </a:defRPr>
             </a:pPr>
             <a:r>
-              <a:t>HORIZONTE DE RETORNO</a:t>
+              <a:t>ECONOMÍA DE ESCALA</a:t>
             </a:r>
           </a:p>
           <a:p>
@@ -6285,7 +7267,7 @@
               </a:defRPr>
             </a:pPr>
             <a:r>
-              <a:t>¿En Qué Tiempo se Visualizan los Ingresos?</a:t>
+              <a:t>Costo Marginal Tendiente a Cero: La Ventaja Tecnológica</a:t>
             </a:r>
           </a:p>
           <a:p>
@@ -6300,600 +7282,7 @@
               </a:defRPr>
             </a:pPr>
             <a:r>
-              <a:t>Roadmap comercial en 3 etapas con metas de facturación auditables desde el Mes 1.</a:t>
-            </a:r>
-          </a:p>
-        </p:txBody>
-      </p:sp>
-      <p:sp>
-        <p:nvSpPr>
-          <p:cNvPr id="4" name="Rounded Rectangle 3"/>
-          <p:cNvSpPr/>
-          <p:nvPr/>
-        </p:nvSpPr>
-        <p:spPr>
-          <a:xfrm>
-            <a:off x="731520" y="1645920"/>
-            <a:ext cx="3429000" cy="4480560"/>
-          </a:xfrm>
-          <a:prstGeom prst="roundRect">
-            <a:avLst/>
-          </a:prstGeom>
-          <a:solidFill>
-            <a:srgbClr val="121E3A"/>
-          </a:solidFill>
-          <a:ln>
-            <a:solidFill>
-              <a:srgbClr val="1E3A64"/>
-            </a:solidFill>
-          </a:ln>
-        </p:spPr>
-        <p:style>
-          <a:lnRef idx="1">
-            <a:schemeClr val="accent1"/>
-          </a:lnRef>
-          <a:fillRef idx="3">
-            <a:schemeClr val="accent1"/>
-          </a:fillRef>
-          <a:effectRef idx="2">
-            <a:schemeClr val="accent1"/>
-          </a:effectRef>
-          <a:fontRef idx="minor">
-            <a:schemeClr val="lt1"/>
-          </a:fontRef>
-        </p:style>
-        <p:txBody>
-          <a:bodyPr rtlCol="0" anchor="ctr" wrap="square" tIns="228600" lIns="228600"/>
-          <a:lstStyle/>
-          <a:p>
-            <a:pPr algn="ctr">
-              <a:defRPr sz="1100" b="1">
-                <a:solidFill>
-                  <a:srgbClr val="F43F5E"/>
-                </a:solidFill>
-              </a:defRPr>
-            </a:pPr>
-            <a:r>
-              <a:t>FASE 1: QUICK WINS</a:t>
-            </a:r>
-          </a:p>
-          <a:p>
-            <a:pPr>
-              <a:spcBef>
-                <a:spcPts val="300"/>
-              </a:spcBef>
-              <a:defRPr sz="1600" b="1">
-                <a:solidFill>
-                  <a:srgbClr val="FFFFFF"/>
-                </a:solidFill>
-              </a:defRPr>
-            </a:pPr>
-            <a:r>
-              <a:t>Meses 1 a 3</a:t>
-            </a:r>
-          </a:p>
-          <a:p>
-            <a:pPr>
-              <a:spcBef>
-                <a:spcPts val="600"/>
-              </a:spcBef>
-              <a:defRPr sz="1200" b="1">
-                <a:solidFill>
-                  <a:srgbClr val="10B981"/>
-                </a:solidFill>
-              </a:defRPr>
-            </a:pPr>
-            <a:r>
-              <a:t>Meta: $80k - $120k / mes</a:t>
-            </a:r>
-          </a:p>
-          <a:p>
-            <a:pPr>
-              <a:spcBef>
-                <a:spcPts val="800"/>
-              </a:spcBef>
-              <a:defRPr sz="950">
-                <a:solidFill>
-                  <a:srgbClr val="CBD5E1"/>
-                </a:solidFill>
-              </a:defRPr>
-            </a:pPr>
-            <a:r>
-              <a:t>• Activación en WhatsApp y PWA de la base actual.</a:t>
-            </a:r>
-          </a:p>
-          <a:p>
-            <a:pPr>
-              <a:spcBef>
-                <a:spcPts val="800"/>
-              </a:spcBef>
-              <a:defRPr sz="950">
-                <a:solidFill>
-                  <a:srgbClr val="CBD5E1"/>
-                </a:solidFill>
-              </a:defRPr>
-            </a:pPr>
-            <a:r>
-              <a:t>• Recargas Pago Móvil C2P en 12 segundos.</a:t>
-            </a:r>
-          </a:p>
-          <a:p>
-            <a:pPr>
-              <a:spcBef>
-                <a:spcPts val="800"/>
-              </a:spcBef>
-              <a:defRPr sz="950">
-                <a:solidFill>
-                  <a:srgbClr val="CBD5E1"/>
-                </a:solidFill>
-              </a:defRPr>
-            </a:pPr>
-            <a:r>
-              <a:t>• Venta automática de Extra Datos al consultar saldo.</a:t>
-            </a:r>
-          </a:p>
-          <a:p>
-            <a:pPr>
-              <a:spcBef>
-                <a:spcPts val="800"/>
-              </a:spcBef>
-              <a:defRPr sz="950">
-                <a:solidFill>
-                  <a:srgbClr val="CBD5E1"/>
-                </a:solidFill>
-              </a:defRPr>
-            </a:pPr>
-            <a:r>
-              <a:t>• Impacto en caja visible en los primeros 30 días.</a:t>
-            </a:r>
-          </a:p>
-        </p:txBody>
-      </p:sp>
-      <p:sp>
-        <p:nvSpPr>
-          <p:cNvPr id="5" name="Rounded Rectangle 4"/>
-          <p:cNvSpPr/>
-          <p:nvPr/>
-        </p:nvSpPr>
-        <p:spPr>
-          <a:xfrm>
-            <a:off x="4343400" y="1645920"/>
-            <a:ext cx="3429000" cy="4480560"/>
-          </a:xfrm>
-          <a:prstGeom prst="roundRect">
-            <a:avLst/>
-          </a:prstGeom>
-          <a:solidFill>
-            <a:srgbClr val="121E3A"/>
-          </a:solidFill>
-          <a:ln>
-            <a:solidFill>
-              <a:srgbClr val="1E3A64"/>
-            </a:solidFill>
-          </a:ln>
-        </p:spPr>
-        <p:style>
-          <a:lnRef idx="1">
-            <a:schemeClr val="accent1"/>
-          </a:lnRef>
-          <a:fillRef idx="3">
-            <a:schemeClr val="accent1"/>
-          </a:fillRef>
-          <a:effectRef idx="2">
-            <a:schemeClr val="accent1"/>
-          </a:effectRef>
-          <a:fontRef idx="minor">
-            <a:schemeClr val="lt1"/>
-          </a:fontRef>
-        </p:style>
-        <p:txBody>
-          <a:bodyPr rtlCol="0" anchor="ctr" wrap="square" tIns="228600" lIns="228600"/>
-          <a:lstStyle/>
-          <a:p>
-            <a:pPr algn="ctr">
-              <a:defRPr sz="1100" b="1">
-                <a:solidFill>
-                  <a:srgbClr val="F59E0B"/>
-                </a:solidFill>
-              </a:defRPr>
-            </a:pPr>
-            <a:r>
-              <a:t>FASE 2: ESCALAMIENTO RETAIL</a:t>
-            </a:r>
-          </a:p>
-          <a:p>
-            <a:pPr>
-              <a:spcBef>
-                <a:spcPts val="300"/>
-              </a:spcBef>
-              <a:defRPr sz="1600" b="1">
-                <a:solidFill>
-                  <a:srgbClr val="FFFFFF"/>
-                </a:solidFill>
-              </a:defRPr>
-            </a:pPr>
-            <a:r>
-              <a:t>Meses 4 a 6</a:t>
-            </a:r>
-          </a:p>
-          <a:p>
-            <a:pPr>
-              <a:spcBef>
-                <a:spcPts val="600"/>
-              </a:spcBef>
-              <a:defRPr sz="1200" b="1">
-                <a:solidFill>
-                  <a:srgbClr val="10B981"/>
-                </a:solidFill>
-              </a:defRPr>
-            </a:pPr>
-            <a:r>
-              <a:t>Meta: $250k - $380k / mes</a:t>
-            </a:r>
-          </a:p>
-          <a:p>
-            <a:pPr>
-              <a:spcBef>
-                <a:spcPts val="800"/>
-              </a:spcBef>
-              <a:defRPr sz="950">
-                <a:solidFill>
-                  <a:srgbClr val="CBD5E1"/>
-                </a:solidFill>
-              </a:defRPr>
-            </a:pPr>
-            <a:r>
-              <a:t>• Onboarding de 150 comercios en Cazador de Ofertas.</a:t>
-            </a:r>
-          </a:p>
-          <a:p>
-            <a:pPr>
-              <a:spcBef>
-                <a:spcPts val="800"/>
-              </a:spcBef>
-              <a:defRPr sz="950">
-                <a:solidFill>
-                  <a:srgbClr val="CBD5E1"/>
-                </a:solidFill>
-              </a:defRPr>
-            </a:pPr>
-            <a:r>
-              <a:t>• Campañas geolocalizadas por radiobases.</a:t>
-            </a:r>
-          </a:p>
-          <a:p>
-            <a:pPr>
-              <a:spcBef>
-                <a:spcPts val="800"/>
-              </a:spcBef>
-              <a:defRPr sz="950">
-                <a:solidFill>
-                  <a:srgbClr val="CBD5E1"/>
-                </a:solidFill>
-              </a:defRPr>
-            </a:pPr>
-            <a:r>
-              <a:t>• Validación visual de comprobantes bancarios por OCR.</a:t>
-            </a:r>
-          </a:p>
-          <a:p>
-            <a:pPr>
-              <a:spcBef>
-                <a:spcPts val="800"/>
-              </a:spcBef>
-              <a:defRPr sz="950">
-                <a:solidFill>
-                  <a:srgbClr val="CBD5E1"/>
-                </a:solidFill>
-              </a:defRPr>
-            </a:pPr>
-            <a:r>
-              <a:t>• Facturación publicitaria masiva en grandes cadenas.</a:t>
-            </a:r>
-          </a:p>
-        </p:txBody>
-      </p:sp>
-      <p:sp>
-        <p:nvSpPr>
-          <p:cNvPr id="6" name="Rounded Rectangle 5"/>
-          <p:cNvSpPr/>
-          <p:nvPr/>
-        </p:nvSpPr>
-        <p:spPr>
-          <a:xfrm>
-            <a:off x="7955280" y="1645920"/>
-            <a:ext cx="3429000" cy="4480560"/>
-          </a:xfrm>
-          <a:prstGeom prst="roundRect">
-            <a:avLst/>
-          </a:prstGeom>
-          <a:solidFill>
-            <a:srgbClr val="121E3A"/>
-          </a:solidFill>
-          <a:ln>
-            <a:solidFill>
-              <a:srgbClr val="1E3A64"/>
-            </a:solidFill>
-          </a:ln>
-        </p:spPr>
-        <p:style>
-          <a:lnRef idx="1">
-            <a:schemeClr val="accent1"/>
-          </a:lnRef>
-          <a:fillRef idx="3">
-            <a:schemeClr val="accent1"/>
-          </a:fillRef>
-          <a:effectRef idx="2">
-            <a:schemeClr val="accent1"/>
-          </a:effectRef>
-          <a:fontRef idx="minor">
-            <a:schemeClr val="lt1"/>
-          </a:fontRef>
-        </p:style>
-        <p:txBody>
-          <a:bodyPr rtlCol="0" anchor="ctr" wrap="square" tIns="228600" lIns="228600"/>
-          <a:lstStyle/>
-          <a:p>
-            <a:pPr algn="ctr">
-              <a:defRPr sz="1100" b="1">
-                <a:solidFill>
-                  <a:srgbClr val="10B981"/>
-                </a:solidFill>
-              </a:defRPr>
-            </a:pPr>
-            <a:r>
-              <a:t>FASE 3: CONQUISTA TOTAL</a:t>
-            </a:r>
-          </a:p>
-          <a:p>
-            <a:pPr>
-              <a:spcBef>
-                <a:spcPts val="300"/>
-              </a:spcBef>
-              <a:defRPr sz="1600" b="1">
-                <a:solidFill>
-                  <a:srgbClr val="FFFFFF"/>
-                </a:solidFill>
-              </a:defRPr>
-            </a:pPr>
-            <a:r>
-              <a:t>Meses 7 a 12</a:t>
-            </a:r>
-          </a:p>
-          <a:p>
-            <a:pPr>
-              <a:spcBef>
-                <a:spcPts val="600"/>
-              </a:spcBef>
-              <a:defRPr sz="1200" b="1">
-                <a:solidFill>
-                  <a:srgbClr val="10B981"/>
-                </a:solidFill>
-              </a:defRPr>
-            </a:pPr>
-            <a:r>
-              <a:t>Meta: $500k - $800k / mes</a:t>
-            </a:r>
-          </a:p>
-          <a:p>
-            <a:pPr>
-              <a:spcBef>
-                <a:spcPts val="800"/>
-              </a:spcBef>
-              <a:defRPr sz="950">
-                <a:solidFill>
-                  <a:srgbClr val="CBD5E1"/>
-                </a:solidFill>
-              </a:defRPr>
-            </a:pPr>
-            <a:r>
-              <a:t>• Portabilidad Express eSIM para Digitel y Movistar.</a:t>
-            </a:r>
-          </a:p>
-          <a:p>
-            <a:pPr>
-              <a:spcBef>
-                <a:spcPts val="800"/>
-              </a:spcBef>
-              <a:defRPr sz="950">
-                <a:solidFill>
-                  <a:srgbClr val="CBD5E1"/>
-                </a:solidFill>
-              </a:defRPr>
-            </a:pPr>
-            <a:r>
-              <a:t>• Carrier Billing para deportes (LVBP) y streaming.</a:t>
-            </a:r>
-          </a:p>
-          <a:p>
-            <a:pPr>
-              <a:spcBef>
-                <a:spcPts val="800"/>
-              </a:spcBef>
-              <a:defRPr sz="950">
-                <a:solidFill>
-                  <a:srgbClr val="CBD5E1"/>
-                </a:solidFill>
-              </a:defRPr>
-            </a:pPr>
-            <a:r>
-              <a:t>• Micro-seguros con cobro directo a saldo.</a:t>
-            </a:r>
-          </a:p>
-          <a:p>
-            <a:pPr>
-              <a:spcBef>
-                <a:spcPts val="800"/>
-              </a:spcBef>
-              <a:defRPr sz="950">
-                <a:solidFill>
-                  <a:srgbClr val="CBD5E1"/>
-                </a:solidFill>
-              </a:defRPr>
-            </a:pPr>
-            <a:r>
-              <a:t>• Consolidación del régimen comercial permanente.</a:t>
-            </a:r>
-          </a:p>
-        </p:txBody>
-      </p:sp>
-      <p:sp>
-        <p:nvSpPr>
-          <p:cNvPr id="7" name="TextBox 6"/>
-          <p:cNvSpPr txBox="1"/>
-          <p:nvPr/>
-        </p:nvSpPr>
-        <p:spPr>
-          <a:xfrm>
-            <a:off x="731520" y="6446520"/>
-            <a:ext cx="10698480" cy="320040"/>
-          </a:xfrm>
-          <a:prstGeom prst="rect">
-            <a:avLst/>
-          </a:prstGeom>
-          <a:noFill/>
-        </p:spPr>
-        <p:txBody>
-          <a:bodyPr wrap="none" lIns="0" tIns="0" rIns="0" bIns="0">
-            <a:spAutoFit/>
-          </a:bodyPr>
-          <a:lstStyle/>
-          <a:p>
-            <a:pPr>
-              <a:defRPr sz="850">
-                <a:solidFill>
-                  <a:srgbClr val="94A3B8"/>
-                </a:solidFill>
-              </a:defRPr>
-            </a:pPr>
-            <a:r>
-              <a:t>🌐 Portal PWA 4GMAX: https://one21026-ids-movilnet-pwa-bxmz.onrender.com/ui/pwa_stitch/index.html  |  Telecomunicaciones Movilnet C.A.</a:t>
-            </a:r>
-          </a:p>
-        </p:txBody>
-      </p:sp>
-    </p:spTree>
-  </p:cSld>
-  <p:clrMapOvr>
-    <a:masterClrMapping/>
-  </p:clrMapOvr>
-</p:sld>
-</file>
-
-<file path=ppt/slides/slide7.xml><?xml version="1.0" encoding="utf-8"?>
-<p:sld xmlns:a="http://schemas.openxmlformats.org/drawingml/2006/main" xmlns:p="http://schemas.openxmlformats.org/presentationml/2006/main" xmlns:r="http://schemas.openxmlformats.org/officeDocument/2006/relationships">
-  <p:cSld>
-    <p:spTree>
-      <p:nvGrpSpPr>
-        <p:cNvPr id="1" name=""/>
-        <p:cNvGrpSpPr/>
-        <p:nvPr/>
-      </p:nvGrpSpPr>
-      <p:grpSpPr/>
-      <p:sp>
-        <p:nvSpPr>
-          <p:cNvPr id="2" name="Rectangle 1"/>
-          <p:cNvSpPr/>
-          <p:nvPr/>
-        </p:nvSpPr>
-        <p:spPr>
-          <a:xfrm>
-            <a:off x="0" y="0"/>
-            <a:ext cx="12191695" cy="6858000"/>
-          </a:xfrm>
-          <a:prstGeom prst="rect">
-            <a:avLst/>
-          </a:prstGeom>
-          <a:solidFill>
-            <a:srgbClr val="0B132B"/>
-          </a:solidFill>
-          <a:ln>
-            <a:noFill/>
-          </a:ln>
-        </p:spPr>
-        <p:style>
-          <a:lnRef idx="1">
-            <a:schemeClr val="accent1"/>
-          </a:lnRef>
-          <a:fillRef idx="3">
-            <a:schemeClr val="accent1"/>
-          </a:fillRef>
-          <a:effectRef idx="2">
-            <a:schemeClr val="accent1"/>
-          </a:effectRef>
-          <a:fontRef idx="minor">
-            <a:schemeClr val="lt1"/>
-          </a:fontRef>
-        </p:style>
-        <p:txBody>
-          <a:bodyPr rtlCol="0" anchor="ctr"/>
-          <a:lstStyle/>
-          <a:p>
-            <a:pPr algn="ctr"/>
-          </a:p>
-        </p:txBody>
-      </p:sp>
-      <p:sp>
-        <p:nvSpPr>
-          <p:cNvPr id="3" name="TextBox 2"/>
-          <p:cNvSpPr txBox="1"/>
-          <p:nvPr/>
-        </p:nvSpPr>
-        <p:spPr>
-          <a:xfrm>
-            <a:off x="731520" y="365760"/>
-            <a:ext cx="10698480" cy="1005840"/>
-          </a:xfrm>
-          <a:prstGeom prst="rect">
-            <a:avLst/>
-          </a:prstGeom>
-          <a:noFill/>
-        </p:spPr>
-        <p:txBody>
-          <a:bodyPr wrap="square" lIns="0" tIns="0" rIns="0" bIns="0">
-            <a:spAutoFit/>
-          </a:bodyPr>
-          <a:lstStyle/>
-          <a:p>
-            <a:pPr>
-              <a:defRPr sz="1000" b="1">
-                <a:solidFill>
-                  <a:srgbClr val="E62020"/>
-                </a:solidFill>
-              </a:defRPr>
-            </a:pPr>
-            <a:r>
-              <a:t>ECONOMÍA DE ESCALA</a:t>
-            </a:r>
-          </a:p>
-          <a:p>
-            <a:pPr>
-              <a:spcBef>
-                <a:spcPts val="300"/>
-              </a:spcBef>
-              <a:defRPr sz="2200" b="1">
-                <a:solidFill>
-                  <a:srgbClr val="FFFFFF"/>
-                </a:solidFill>
-              </a:defRPr>
-            </a:pPr>
-            <a:r>
-              <a:t>Costo Marginal Tendiente a Cero: La Ventaja Tecnológica</a:t>
-            </a:r>
-          </a:p>
-          <a:p>
-            <a:pPr>
-              <a:spcBef>
-                <a:spcPts val="200"/>
-              </a:spcBef>
-              <a:defRPr sz="1100">
-                <a:solidFill>
-                  <a:srgbClr val="94A3B8"/>
-                </a:solidFill>
-              </a:defRPr>
-            </a:pPr>
-            <a:r>
-              <a:t>Cómo la combinación de Sistema 1 (FastPath) y Sistema 2 (IA Multimodal) maximiza el margen.</a:t>
+              <a:t>Cómo la combinación de Sistema 1 (FastPath) y Sistema 2 (IA Multimodal) maximiza el margen con CAC = $0.</a:t>
             </a:r>
           </a:p>
         </p:txBody>
@@ -6940,7 +7329,7 @@
           <a:lstStyle/>
           <a:p>
             <a:pPr algn="ctr">
-              <a:defRPr sz="1200" b="1">
+              <a:defRPr sz="1150" b="1">
                 <a:solidFill>
                   <a:srgbClr val="0EA5E9"/>
                 </a:solidFill>
@@ -6955,7 +7344,7 @@
               <a:spcBef>
                 <a:spcPts val="1000"/>
               </a:spcBef>
-              <a:defRPr sz="1100" b="1">
+              <a:defRPr sz="1050" b="1">
                 <a:solidFill>
                   <a:srgbClr val="10B981"/>
                 </a:solidFill>
@@ -6970,14 +7359,14 @@
               <a:spcBef>
                 <a:spcPts val="300"/>
               </a:spcBef>
-              <a:defRPr sz="1000">
+              <a:defRPr sz="950">
                 <a:solidFill>
                   <a:srgbClr val="CBD5E1"/>
                 </a:solidFill>
               </a:defRPr>
             </a:pPr>
             <a:r>
-              <a:t>Consultas de saldo, corte y paquetes se resuelven en memoria RAM local en &lt;1 milisegundo a CERO costo de tokens ($0.0000 USD).</a:t>
+              <a:t>Consultas de saldo, corte y paquetes se resuelven en memoria RAM local en &lt;1 ms a CERO costo de tokens ($0.0000 USD).</a:t>
             </a:r>
           </a:p>
           <a:p>
@@ -6985,7 +7374,7 @@
               <a:spcBef>
                 <a:spcPts val="1200"/>
               </a:spcBef>
-              <a:defRPr sz="1100" b="1">
+              <a:defRPr sz="1050" b="1">
                 <a:solidFill>
                   <a:srgbClr val="A855F7"/>
                 </a:solidFill>
@@ -7000,14 +7389,14 @@
               <a:spcBef>
                 <a:spcPts val="300"/>
               </a:spcBef>
-              <a:defRPr sz="1000">
+              <a:defRPr sz="950">
                 <a:solidFill>
                   <a:srgbClr val="CBD5E1"/>
                 </a:solidFill>
               </a:defRPr>
             </a:pPr>
             <a:r>
-              <a:t>Solo se activa para auditar imágenes de comprobantes de pago bancarios y notas de voz con costo mínimo de $0.0008 USD.</a:t>
+              <a:t>Solo se activa para auditar imágenes de comprobantes bancarios y notas de voz con costo de $0.0008 USD.</a:t>
             </a:r>
           </a:p>
         </p:txBody>
@@ -7054,14 +7443,14 @@
           <a:lstStyle/>
           <a:p>
             <a:pPr algn="ctr">
-              <a:defRPr sz="1200" b="1">
+              <a:defRPr sz="1150" b="1">
                 <a:solidFill>
                   <a:srgbClr val="F59E0B"/>
                 </a:solidFill>
               </a:defRPr>
             </a:pPr>
             <a:r>
-              <a:t>📉 COSTO POR USUARIO / MES AL ESCALAR</a:t>
+              <a:t>📉 COSTO POR USUARIO / MES AL ESCALAR (CAC = $0)</a:t>
             </a:r>
           </a:p>
           <a:p>
@@ -7069,7 +7458,7 @@
               <a:spcBef>
                 <a:spcPts val="1200"/>
               </a:spcBef>
-              <a:defRPr sz="1100" b="1">
+              <a:defRPr sz="1050" b="1">
                 <a:solidFill>
                   <a:srgbClr val="FFFFFF"/>
                 </a:solidFill>
@@ -7084,7 +7473,7 @@
               <a:spcBef>
                 <a:spcPts val="1200"/>
               </a:spcBef>
-              <a:defRPr sz="1100" b="1">
+              <a:defRPr sz="1050" b="1">
                 <a:solidFill>
                   <a:srgbClr val="FFFFFF"/>
                 </a:solidFill>
@@ -7099,7 +7488,7 @@
               <a:spcBef>
                 <a:spcPts val="1200"/>
               </a:spcBef>
-              <a:defRPr sz="1100" b="1">
+              <a:defRPr sz="1050" b="1">
                 <a:solidFill>
                   <a:srgbClr val="FFFFFF"/>
                 </a:solidFill>
@@ -7114,14 +7503,14 @@
               <a:spcBef>
                 <a:spcPts val="1600"/>
               </a:spcBef>
-              <a:defRPr sz="1000" i="1">
+              <a:defRPr sz="950" i="1">
                 <a:solidFill>
                   <a:srgbClr val="94A3B8"/>
                 </a:solidFill>
               </a:defRPr>
             </a:pPr>
             <a:r>
-              <a:t>Conclusión Económica: A mayor volumen de usuarios, el costo unitario tiende asintóticamente a cero, expandiendo el margen bruto por encima del 80%.</a:t>
+              <a:t>Conclusión para el Inversor: Al asumir Movilnet el 100% del marketing y aportar 4.2M de usuarios, el CAC es $0 y el margen operativo supera el 85%.</a:t>
             </a:r>
           </a:p>
         </p:txBody>
@@ -7169,7 +7558,7 @@
 </p:sld>
 </file>
 
-<file path=ppt/slides/slide8.xml><?xml version="1.0" encoding="utf-8"?>
+<file path=ppt/slides/slide9.xml><?xml version="1.0" encoding="utf-8"?>
 <p:sld xmlns:a="http://schemas.openxmlformats.org/drawingml/2006/main" xmlns:p="http://schemas.openxmlformats.org/presentationml/2006/main" xmlns:r="http://schemas.openxmlformats.org/officeDocument/2006/relationships">
   <p:cSld>
     <p:spTree>
@@ -7267,7 +7656,7 @@
               </a:defRPr>
             </a:pPr>
             <a:r>
-              <a:t>Estado de Resultados Proyectado (36 Meses en Miles USD)</a:t>
+              <a:t>Estado de Resultados Consolidado (36 Meses en Miles USD)</a:t>
             </a:r>
           </a:p>
           <a:p>
@@ -7282,7 +7671,7 @@
               </a:defRPr>
             </a:pPr>
             <a:r>
-              <a:t>Proyección financiera consolidada basada en supuestos conservadores de adopción.</a:t>
+              <a:t>Proyección financiera basada en la adopción masiva impulsada por los Tours y Canales Oficiales.</a:t>
             </a:r>
           </a:p>
         </p:txBody>
@@ -7412,7 +7801,7 @@
                     <a:lstStyle/>
                     <a:p>
                       <a:pPr>
-                        <a:defRPr sz="1050" b="0">
+                        <a:defRPr sz="1000" b="0">
                           <a:solidFill>
                             <a:srgbClr val="FFFFFF"/>
                           </a:solidFill>
@@ -7435,7 +7824,7 @@
                     <a:lstStyle/>
                     <a:p>
                       <a:pPr>
-                        <a:defRPr sz="1050" b="0">
+                        <a:defRPr sz="1000" b="0">
                           <a:solidFill>
                             <a:srgbClr val="FFFFFF"/>
                           </a:solidFill>
@@ -7458,7 +7847,7 @@
                     <a:lstStyle/>
                     <a:p>
                       <a:pPr>
-                        <a:defRPr sz="1050" b="0">
+                        <a:defRPr sz="1000" b="0">
                           <a:solidFill>
                             <a:srgbClr val="FFFFFF"/>
                           </a:solidFill>
@@ -7481,7 +7870,7 @@
                     <a:lstStyle/>
                     <a:p>
                       <a:pPr>
-                        <a:defRPr sz="1050" b="0">
+                        <a:defRPr sz="1000" b="0">
                           <a:solidFill>
                             <a:srgbClr val="FFFFFF"/>
                           </a:solidFill>
@@ -7506,7 +7895,7 @@
                     <a:lstStyle/>
                     <a:p>
                       <a:pPr>
-                        <a:defRPr sz="1050" b="0">
+                        <a:defRPr sz="1000" b="0">
                           <a:solidFill>
                             <a:srgbClr val="FFFFFF"/>
                           </a:solidFill>
@@ -7529,14 +7918,14 @@
                     <a:lstStyle/>
                     <a:p>
                       <a:pPr>
-                        <a:defRPr sz="1050" b="0">
+                        <a:defRPr sz="1000" b="0">
                           <a:solidFill>
                             <a:srgbClr val="FFFFFF"/>
                           </a:solidFill>
                         </a:defRPr>
                       </a:pPr>
                       <a:r>
-                        <a:t>$720</a:t>
+                        <a:t>$840</a:t>
                       </a:r>
                     </a:p>
                   </a:txBody>
@@ -7552,14 +7941,14 @@
                     <a:lstStyle/>
                     <a:p>
                       <a:pPr>
-                        <a:defRPr sz="1050" b="0">
+                        <a:defRPr sz="1000" b="0">
                           <a:solidFill>
                             <a:srgbClr val="FFFFFF"/>
                           </a:solidFill>
                         </a:defRPr>
                       </a:pPr>
                       <a:r>
-                        <a:t>$1,800</a:t>
+                        <a:t>$2,100</a:t>
                       </a:r>
                     </a:p>
                   </a:txBody>
@@ -7575,14 +7964,14 @@
                     <a:lstStyle/>
                     <a:p>
                       <a:pPr>
-                        <a:defRPr sz="1050" b="0">
+                        <a:defRPr sz="1000" b="0">
                           <a:solidFill>
                             <a:srgbClr val="FFFFFF"/>
                           </a:solidFill>
                         </a:defRPr>
                       </a:pPr>
                       <a:r>
-                        <a:t>$2,880</a:t>
+                        <a:t>$3,360</a:t>
                       </a:r>
                     </a:p>
                   </a:txBody>
@@ -7600,7 +7989,7 @@
                     <a:lstStyle/>
                     <a:p>
                       <a:pPr>
-                        <a:defRPr sz="1050" b="0">
+                        <a:defRPr sz="1000" b="0">
                           <a:solidFill>
                             <a:srgbClr val="FFFFFF"/>
                           </a:solidFill>
@@ -7623,14 +8012,14 @@
                     <a:lstStyle/>
                     <a:p>
                       <a:pPr>
-                        <a:defRPr sz="1050" b="0">
+                        <a:defRPr sz="1000" b="0">
                           <a:solidFill>
                             <a:srgbClr val="FFFFFF"/>
                           </a:solidFill>
                         </a:defRPr>
                       </a:pPr>
                       <a:r>
-                        <a:t>$360</a:t>
+                        <a:t>$420</a:t>
                       </a:r>
                     </a:p>
                   </a:txBody>
@@ -7646,14 +8035,14 @@
                     <a:lstStyle/>
                     <a:p>
                       <a:pPr>
-                        <a:defRPr sz="1050" b="0">
+                        <a:defRPr sz="1000" b="0">
                           <a:solidFill>
                             <a:srgbClr val="FFFFFF"/>
                           </a:solidFill>
                         </a:defRPr>
                       </a:pPr>
                       <a:r>
-                        <a:t>$1,152</a:t>
+                        <a:t>$1,344</a:t>
                       </a:r>
                     </a:p>
                   </a:txBody>
@@ -7669,14 +8058,14 @@
                     <a:lstStyle/>
                     <a:p>
                       <a:pPr>
-                        <a:defRPr sz="1050" b="0">
+                        <a:defRPr sz="1000" b="0">
                           <a:solidFill>
                             <a:srgbClr val="FFFFFF"/>
                           </a:solidFill>
                         </a:defRPr>
                       </a:pPr>
                       <a:r>
-                        <a:t>$2,304</a:t>
+                        <a:t>$2,688</a:t>
                       </a:r>
                     </a:p>
                   </a:txBody>
@@ -7694,7 +8083,7 @@
                     <a:lstStyle/>
                     <a:p>
                       <a:pPr>
-                        <a:defRPr sz="1050" b="0">
+                        <a:defRPr sz="1000" b="0">
                           <a:solidFill>
                             <a:srgbClr val="FFFFFF"/>
                           </a:solidFill>
@@ -7717,14 +8106,14 @@
                     <a:lstStyle/>
                     <a:p>
                       <a:pPr>
-                        <a:defRPr sz="1050" b="0">
+                        <a:defRPr sz="1000" b="0">
                           <a:solidFill>
                             <a:srgbClr val="FFFFFF"/>
                           </a:solidFill>
                         </a:defRPr>
                       </a:pPr>
                       <a:r>
-                        <a:t>$216</a:t>
+                        <a:t>$252</a:t>
                       </a:r>
                     </a:p>
                   </a:txBody>
@@ -7740,14 +8129,14 @@
                     <a:lstStyle/>
                     <a:p>
                       <a:pPr>
-                        <a:defRPr sz="1050" b="0">
+                        <a:defRPr sz="1000" b="0">
                           <a:solidFill>
                             <a:srgbClr val="FFFFFF"/>
                           </a:solidFill>
                         </a:defRPr>
                       </a:pPr>
                       <a:r>
-                        <a:t>$648</a:t>
+                        <a:t>$756</a:t>
                       </a:r>
                     </a:p>
                   </a:txBody>
@@ -7763,14 +8152,14 @@
                     <a:lstStyle/>
                     <a:p>
                       <a:pPr>
-                        <a:defRPr sz="1050" b="0">
+                        <a:defRPr sz="1000" b="0">
                           <a:solidFill>
                             <a:srgbClr val="FFFFFF"/>
                           </a:solidFill>
                         </a:defRPr>
                       </a:pPr>
                       <a:r>
-                        <a:t>$1,152</a:t>
+                        <a:t>$1,344</a:t>
                       </a:r>
                     </a:p>
                   </a:txBody>
@@ -7788,7 +8177,7 @@
                     <a:lstStyle/>
                     <a:p>
                       <a:pPr>
-                        <a:defRPr sz="1050" b="1">
+                        <a:defRPr sz="1000" b="1">
                           <a:solidFill>
                             <a:srgbClr val="FFFFFF"/>
                           </a:solidFill>
@@ -7811,14 +8200,14 @@
                     <a:lstStyle/>
                     <a:p>
                       <a:pPr>
-                        <a:defRPr sz="1050" b="1">
+                        <a:defRPr sz="1000" b="1">
                           <a:solidFill>
                             <a:srgbClr val="10B981"/>
                           </a:solidFill>
                         </a:defRPr>
                       </a:pPr>
                       <a:r>
-                        <a:t>$2,520</a:t>
+                        <a:t>$2,736</a:t>
                       </a:r>
                     </a:p>
                   </a:txBody>
@@ -7834,14 +8223,14 @@
                     <a:lstStyle/>
                     <a:p>
                       <a:pPr>
-                        <a:defRPr sz="1050" b="1">
+                        <a:defRPr sz="1000" b="1">
                           <a:solidFill>
                             <a:srgbClr val="10B981"/>
                           </a:solidFill>
                         </a:defRPr>
                       </a:pPr>
                       <a:r>
-                        <a:t>$6,048</a:t>
+                        <a:t>$6,648</a:t>
                       </a:r>
                     </a:p>
                   </a:txBody>
@@ -7857,14 +8246,14 @@
                     <a:lstStyle/>
                     <a:p>
                       <a:pPr>
-                        <a:defRPr sz="1050" b="1">
+                        <a:defRPr sz="1000" b="1">
                           <a:solidFill>
                             <a:srgbClr val="10B981"/>
                           </a:solidFill>
                         </a:defRPr>
                       </a:pPr>
                       <a:r>
-                        <a:t>$9,600</a:t>
+                        <a:t>$10,656</a:t>
                       </a:r>
                     </a:p>
                   </a:txBody>
@@ -7882,7 +8271,7 @@
                     <a:lstStyle/>
                     <a:p>
                       <a:pPr>
-                        <a:defRPr sz="1050" b="1">
+                        <a:defRPr sz="1000" b="1">
                           <a:solidFill>
                             <a:srgbClr val="FFFFFF"/>
                           </a:solidFill>
@@ -7905,14 +8294,14 @@
                     <a:lstStyle/>
                     <a:p>
                       <a:pPr>
-                        <a:defRPr sz="1050" b="1">
+                        <a:defRPr sz="1000" b="1">
                           <a:solidFill>
                             <a:srgbClr val="10B981"/>
                           </a:solidFill>
                         </a:defRPr>
                       </a:pPr>
                       <a:r>
-                        <a:t>$1,975 (78.4%)</a:t>
+                        <a:t>$2,331 (85.2%)</a:t>
                       </a:r>
                     </a:p>
                   </a:txBody>
@@ -7928,14 +8317,14 @@
                     <a:lstStyle/>
                     <a:p>
                       <a:pPr>
-                        <a:defRPr sz="1050" b="1">
+                        <a:defRPr sz="1000" b="1">
                           <a:solidFill>
                             <a:srgbClr val="10B981"/>
                           </a:solidFill>
                         </a:defRPr>
                       </a:pPr>
                       <a:r>
-                        <a:t>$5,198 (85.9%)</a:t>
+                        <a:t>$6,008 (90.3%)</a:t>
                       </a:r>
                     </a:p>
                   </a:txBody>
@@ -7951,14 +8340,14 @@
                     <a:lstStyle/>
                     <a:p>
                       <a:pPr>
-                        <a:defRPr sz="1050" b="1">
+                        <a:defRPr sz="1000" b="1">
                           <a:solidFill>
                             <a:srgbClr val="10B981"/>
                           </a:solidFill>
                         </a:defRPr>
                       </a:pPr>
                       <a:r>
-                        <a:t>$8,520 (88.8%)</a:t>
+                        <a:t>$9,816 (92.1%)</a:t>
                       </a:r>
                     </a:p>
                   </a:txBody>
@@ -7976,503 +8365,6 @@
       <p:sp>
         <p:nvSpPr>
           <p:cNvPr id="5" name="TextBox 4"/>
-          <p:cNvSpPr txBox="1"/>
-          <p:nvPr/>
-        </p:nvSpPr>
-        <p:spPr>
-          <a:xfrm>
-            <a:off x="731520" y="6446520"/>
-            <a:ext cx="10698480" cy="320040"/>
-          </a:xfrm>
-          <a:prstGeom prst="rect">
-            <a:avLst/>
-          </a:prstGeom>
-          <a:noFill/>
-        </p:spPr>
-        <p:txBody>
-          <a:bodyPr wrap="none" lIns="0" tIns="0" rIns="0" bIns="0">
-            <a:spAutoFit/>
-          </a:bodyPr>
-          <a:lstStyle/>
-          <a:p>
-            <a:pPr>
-              <a:defRPr sz="850">
-                <a:solidFill>
-                  <a:srgbClr val="94A3B8"/>
-                </a:solidFill>
-              </a:defRPr>
-            </a:pPr>
-            <a:r>
-              <a:t>🌐 Portal PWA 4GMAX: https://one21026-ids-movilnet-pwa-bxmz.onrender.com/ui/pwa_stitch/index.html  |  Telecomunicaciones Movilnet C.A.</a:t>
-            </a:r>
-          </a:p>
-        </p:txBody>
-      </p:sp>
-    </p:spTree>
-  </p:cSld>
-  <p:clrMapOvr>
-    <a:masterClrMapping/>
-  </p:clrMapOvr>
-</p:sld>
-</file>
-
-<file path=ppt/slides/slide9.xml><?xml version="1.0" encoding="utf-8"?>
-<p:sld xmlns:a="http://schemas.openxmlformats.org/drawingml/2006/main" xmlns:p="http://schemas.openxmlformats.org/presentationml/2006/main" xmlns:r="http://schemas.openxmlformats.org/officeDocument/2006/relationships">
-  <p:cSld>
-    <p:spTree>
-      <p:nvGrpSpPr>
-        <p:cNvPr id="1" name=""/>
-        <p:cNvGrpSpPr/>
-        <p:nvPr/>
-      </p:nvGrpSpPr>
-      <p:grpSpPr/>
-      <p:sp>
-        <p:nvSpPr>
-          <p:cNvPr id="2" name="Rectangle 1"/>
-          <p:cNvSpPr/>
-          <p:nvPr/>
-        </p:nvSpPr>
-        <p:spPr>
-          <a:xfrm>
-            <a:off x="0" y="0"/>
-            <a:ext cx="12191695" cy="6858000"/>
-          </a:xfrm>
-          <a:prstGeom prst="rect">
-            <a:avLst/>
-          </a:prstGeom>
-          <a:solidFill>
-            <a:srgbClr val="0B132B"/>
-          </a:solidFill>
-          <a:ln>
-            <a:noFill/>
-          </a:ln>
-        </p:spPr>
-        <p:style>
-          <a:lnRef idx="1">
-            <a:schemeClr val="accent1"/>
-          </a:lnRef>
-          <a:fillRef idx="3">
-            <a:schemeClr val="accent1"/>
-          </a:fillRef>
-          <a:effectRef idx="2">
-            <a:schemeClr val="accent1"/>
-          </a:effectRef>
-          <a:fontRef idx="minor">
-            <a:schemeClr val="lt1"/>
-          </a:fontRef>
-        </p:style>
-        <p:txBody>
-          <a:bodyPr rtlCol="0" anchor="ctr"/>
-          <a:lstStyle/>
-          <a:p>
-            <a:pPr algn="ctr"/>
-          </a:p>
-        </p:txBody>
-      </p:sp>
-      <p:sp>
-        <p:nvSpPr>
-          <p:cNvPr id="3" name="TextBox 2"/>
-          <p:cNvSpPr txBox="1"/>
-          <p:nvPr/>
-        </p:nvSpPr>
-        <p:spPr>
-          <a:xfrm>
-            <a:off x="731520" y="365760"/>
-            <a:ext cx="10698480" cy="1005840"/>
-          </a:xfrm>
-          <a:prstGeom prst="rect">
-            <a:avLst/>
-          </a:prstGeom>
-          <a:noFill/>
-        </p:spPr>
-        <p:txBody>
-          <a:bodyPr wrap="square" lIns="0" tIns="0" rIns="0" bIns="0">
-            <a:spAutoFit/>
-          </a:bodyPr>
-          <a:lstStyle/>
-          <a:p>
-            <a:pPr>
-              <a:defRPr sz="1000" b="1">
-                <a:solidFill>
-                  <a:srgbClr val="E62020"/>
-                </a:solidFill>
-              </a:defRPr>
-            </a:pPr>
-            <a:r>
-              <a:t>GROWTH &amp; ADQUISICIÓN</a:t>
-            </a:r>
-          </a:p>
-          <a:p>
-            <a:pPr>
-              <a:spcBef>
-                <a:spcPts val="300"/>
-              </a:spcBef>
-              <a:defRPr sz="2200" b="1">
-                <a:solidFill>
-                  <a:srgbClr val="FFFFFF"/>
-                </a:solidFill>
-              </a:defRPr>
-            </a:pPr>
-            <a:r>
-              <a:t>Cómo Capturamos Usuarios de la Competencia</a:t>
-            </a:r>
-          </a:p>
-          <a:p>
-            <a:pPr>
-              <a:spcBef>
-                <a:spcPts val="200"/>
-              </a:spcBef>
-              <a:defRPr sz="1100">
-                <a:solidFill>
-                  <a:srgbClr val="94A3B8"/>
-                </a:solidFill>
-              </a:defRPr>
-            </a:pPr>
-            <a:r>
-              <a:t>Estrategia perimetral para migrar abonados de Digitel y Movistar a costo de adquisición mínimo.</a:t>
-            </a:r>
-          </a:p>
-        </p:txBody>
-      </p:sp>
-      <p:sp>
-        <p:nvSpPr>
-          <p:cNvPr id="4" name="Rounded Rectangle 3"/>
-          <p:cNvSpPr/>
-          <p:nvPr/>
-        </p:nvSpPr>
-        <p:spPr>
-          <a:xfrm>
-            <a:off x="731520" y="1645920"/>
-            <a:ext cx="2560320" cy="4480560"/>
-          </a:xfrm>
-          <a:prstGeom prst="roundRect">
-            <a:avLst/>
-          </a:prstGeom>
-          <a:solidFill>
-            <a:srgbClr val="121E3A"/>
-          </a:solidFill>
-          <a:ln>
-            <a:solidFill>
-              <a:srgbClr val="1E3A64"/>
-            </a:solidFill>
-          </a:ln>
-        </p:spPr>
-        <p:style>
-          <a:lnRef idx="1">
-            <a:schemeClr val="accent1"/>
-          </a:lnRef>
-          <a:fillRef idx="3">
-            <a:schemeClr val="accent1"/>
-          </a:fillRef>
-          <a:effectRef idx="2">
-            <a:schemeClr val="accent1"/>
-          </a:effectRef>
-          <a:fontRef idx="minor">
-            <a:schemeClr val="lt1"/>
-          </a:fontRef>
-        </p:style>
-        <p:txBody>
-          <a:bodyPr rtlCol="0" anchor="ctr" wrap="square" tIns="228600" lIns="182880"/>
-          <a:lstStyle/>
-          <a:p>
-            <a:pPr algn="ctr">
-              <a:defRPr sz="1200" b="1">
-                <a:solidFill>
-                  <a:srgbClr val="FFFFFF"/>
-                </a:solidFill>
-              </a:defRPr>
-            </a:pPr>
-            <a:r>
-              <a:t>1. Detección Perimetral</a:t>
-            </a:r>
-          </a:p>
-          <a:p>
-            <a:pPr>
-              <a:spcBef>
-                <a:spcPts val="800"/>
-              </a:spcBef>
-              <a:defRPr sz="1300" b="1">
-                <a:solidFill>
-                  <a:srgbClr val="A855F7"/>
-                </a:solidFill>
-              </a:defRPr>
-            </a:pPr>
-            <a:r>
-              <a:t>0414 / 0424 / 0412</a:t>
-            </a:r>
-          </a:p>
-          <a:p>
-            <a:pPr>
-              <a:spcBef>
-                <a:spcPts val="1400"/>
-              </a:spcBef>
-              <a:defRPr sz="1000">
-                <a:solidFill>
-                  <a:srgbClr val="CBD5E1"/>
-                </a:solidFill>
-              </a:defRPr>
-            </a:pPr>
-            <a:r>
-              <a:t>El firewall identifica cuando un usuario de la competencia entra al portal o escribe a WhatsApp.</a:t>
-            </a:r>
-          </a:p>
-        </p:txBody>
-      </p:sp>
-      <p:sp>
-        <p:nvSpPr>
-          <p:cNvPr id="5" name="Rounded Rectangle 4"/>
-          <p:cNvSpPr/>
-          <p:nvPr/>
-        </p:nvSpPr>
-        <p:spPr>
-          <a:xfrm>
-            <a:off x="3429000" y="1645920"/>
-            <a:ext cx="2560320" cy="4480560"/>
-          </a:xfrm>
-          <a:prstGeom prst="roundRect">
-            <a:avLst/>
-          </a:prstGeom>
-          <a:solidFill>
-            <a:srgbClr val="121E3A"/>
-          </a:solidFill>
-          <a:ln>
-            <a:solidFill>
-              <a:srgbClr val="1E3A64"/>
-            </a:solidFill>
-          </a:ln>
-        </p:spPr>
-        <p:style>
-          <a:lnRef idx="1">
-            <a:schemeClr val="accent1"/>
-          </a:lnRef>
-          <a:fillRef idx="3">
-            <a:schemeClr val="accent1"/>
-          </a:fillRef>
-          <a:effectRef idx="2">
-            <a:schemeClr val="accent1"/>
-          </a:effectRef>
-          <a:fontRef idx="minor">
-            <a:schemeClr val="lt1"/>
-          </a:fontRef>
-        </p:style>
-        <p:txBody>
-          <a:bodyPr rtlCol="0" anchor="ctr" wrap="square" tIns="228600" lIns="182880"/>
-          <a:lstStyle/>
-          <a:p>
-            <a:pPr algn="ctr">
-              <a:defRPr sz="1200" b="1">
-                <a:solidFill>
-                  <a:srgbClr val="FFFFFF"/>
-                </a:solidFill>
-              </a:defRPr>
-            </a:pPr>
-            <a:r>
-              <a:t>2. Gancho Freemium</a:t>
-            </a:r>
-          </a:p>
-          <a:p>
-            <a:pPr>
-              <a:spcBef>
-                <a:spcPts val="800"/>
-              </a:spcBef>
-              <a:defRPr sz="1300" b="1">
-                <a:solidFill>
-                  <a:srgbClr val="F59E0B"/>
-                </a:solidFill>
-              </a:defRPr>
-            </a:pPr>
-            <a:r>
-              <a:t>1.000 Tokens de Bienvenida</a:t>
-            </a:r>
-          </a:p>
-          <a:p>
-            <a:pPr>
-              <a:spcBef>
-                <a:spcPts val="1400"/>
-              </a:spcBef>
-              <a:defRPr sz="1000">
-                <a:solidFill>
-                  <a:srgbClr val="CBD5E1"/>
-                </a:solidFill>
-              </a:defRPr>
-            </a:pPr>
-            <a:r>
-              <a:t>Se le permite interactuar gratis con MOVI para consultar promociones, demostrando la superioridad del servicio.</a:t>
-            </a:r>
-          </a:p>
-        </p:txBody>
-      </p:sp>
-      <p:sp>
-        <p:nvSpPr>
-          <p:cNvPr id="6" name="Rounded Rectangle 5"/>
-          <p:cNvSpPr/>
-          <p:nvPr/>
-        </p:nvSpPr>
-        <p:spPr>
-          <a:xfrm>
-            <a:off x="6126480" y="1645920"/>
-            <a:ext cx="2560320" cy="4480560"/>
-          </a:xfrm>
-          <a:prstGeom prst="roundRect">
-            <a:avLst/>
-          </a:prstGeom>
-          <a:solidFill>
-            <a:srgbClr val="121E3A"/>
-          </a:solidFill>
-          <a:ln>
-            <a:solidFill>
-              <a:srgbClr val="1E3A64"/>
-            </a:solidFill>
-          </a:ln>
-        </p:spPr>
-        <p:style>
-          <a:lnRef idx="1">
-            <a:schemeClr val="accent1"/>
-          </a:lnRef>
-          <a:fillRef idx="3">
-            <a:schemeClr val="accent1"/>
-          </a:fillRef>
-          <a:effectRef idx="2">
-            <a:schemeClr val="accent1"/>
-          </a:effectRef>
-          <a:fontRef idx="minor">
-            <a:schemeClr val="lt1"/>
-          </a:fontRef>
-        </p:style>
-        <p:txBody>
-          <a:bodyPr rtlCol="0" anchor="ctr" wrap="square" tIns="228600" lIns="182880"/>
-          <a:lstStyle/>
-          <a:p>
-            <a:pPr algn="ctr">
-              <a:defRPr sz="1200" b="1">
-                <a:solidFill>
-                  <a:srgbClr val="FFFFFF"/>
-                </a:solidFill>
-              </a:defRPr>
-            </a:pPr>
-            <a:r>
-              <a:t>3. Portabilidad Express eSIM</a:t>
-            </a:r>
-          </a:p>
-          <a:p>
-            <a:pPr>
-              <a:spcBef>
-                <a:spcPts val="800"/>
-              </a:spcBef>
-              <a:defRPr sz="1300" b="1">
-                <a:solidFill>
-                  <a:srgbClr val="0EA5E9"/>
-                </a:solidFill>
-              </a:defRPr>
-            </a:pPr>
-            <a:r>
-              <a:t>Migración en 3 Minutos</a:t>
-            </a:r>
-          </a:p>
-          <a:p>
-            <a:pPr>
-              <a:spcBef>
-                <a:spcPts val="1400"/>
-              </a:spcBef>
-              <a:defRPr sz="1000">
-                <a:solidFill>
-                  <a:srgbClr val="CBD5E1"/>
-                </a:solidFill>
-              </a:defRPr>
-            </a:pPr>
-            <a:r>
-              <a:t>Se le ofrece conservar su mismo número y pasarse a la red 4GMAX de Movilnet con una eSIM digital instantánea.</a:t>
-            </a:r>
-          </a:p>
-        </p:txBody>
-      </p:sp>
-      <p:sp>
-        <p:nvSpPr>
-          <p:cNvPr id="7" name="Rounded Rectangle 6"/>
-          <p:cNvSpPr/>
-          <p:nvPr/>
-        </p:nvSpPr>
-        <p:spPr>
-          <a:xfrm>
-            <a:off x="8823960" y="1645920"/>
-            <a:ext cx="2560320" cy="4480560"/>
-          </a:xfrm>
-          <a:prstGeom prst="roundRect">
-            <a:avLst/>
-          </a:prstGeom>
-          <a:solidFill>
-            <a:srgbClr val="121E3A"/>
-          </a:solidFill>
-          <a:ln>
-            <a:solidFill>
-              <a:srgbClr val="1E3A64"/>
-            </a:solidFill>
-          </a:ln>
-        </p:spPr>
-        <p:style>
-          <a:lnRef idx="1">
-            <a:schemeClr val="accent1"/>
-          </a:lnRef>
-          <a:fillRef idx="3">
-            <a:schemeClr val="accent1"/>
-          </a:fillRef>
-          <a:effectRef idx="2">
-            <a:schemeClr val="accent1"/>
-          </a:effectRef>
-          <a:fontRef idx="minor">
-            <a:schemeClr val="lt1"/>
-          </a:fontRef>
-        </p:style>
-        <p:txBody>
-          <a:bodyPr rtlCol="0" anchor="ctr" wrap="square" tIns="228600" lIns="182880"/>
-          <a:lstStyle/>
-          <a:p>
-            <a:pPr algn="ctr">
-              <a:defRPr sz="1200" b="1">
-                <a:solidFill>
-                  <a:srgbClr val="FFFFFF"/>
-                </a:solidFill>
-              </a:defRPr>
-            </a:pPr>
-            <a:r>
-              <a:t>4. LTV del Abonado Captado</a:t>
-            </a:r>
-          </a:p>
-          <a:p>
-            <a:pPr>
-              <a:spcBef>
-                <a:spcPts val="800"/>
-              </a:spcBef>
-              <a:defRPr sz="1300" b="1">
-                <a:solidFill>
-                  <a:srgbClr val="10B981"/>
-                </a:solidFill>
-              </a:defRPr>
-            </a:pPr>
-            <a:r>
-              <a:t>$42 USD / Año por Línea</a:t>
-            </a:r>
-          </a:p>
-          <a:p>
-            <a:pPr>
-              <a:spcBef>
-                <a:spcPts val="1400"/>
-              </a:spcBef>
-              <a:defRPr sz="1000">
-                <a:solidFill>
-                  <a:srgbClr val="CBD5E1"/>
-                </a:solidFill>
-              </a:defRPr>
-            </a:pPr>
-            <a:r>
-              <a:t>120.000 líneas captadas representan +$5.04M USD anuales con costo de adquisición (CAC) casi cero.</a:t>
-            </a:r>
-          </a:p>
-        </p:txBody>
-      </p:sp>
-      <p:sp>
-        <p:nvSpPr>
-          <p:cNvPr id="8" name="TextBox 7"/>
           <p:cNvSpPr txBox="1"/>
           <p:nvPr/>
         </p:nvSpPr>

</xml_diff>